<commit_message>
Aumentar tamanho das fontes na apresentacao da aula
Tipografia ampliada em todos os slides (titulos, bullets, versiculos e
cartoes) para melhor leitura na projecao, mantendo a aula em um unico
domingo de 60 minutos (22 slides).

Co-Authored-By: Claude Opus 4.8 <noreply@anthropic.com>
Claude-Session: https://claude.ai/code/session_018DWkv9fk9v8qeNWX5qbDjs
</commit_message>
<xml_diff>
--- a/aula-somos-um-em-cristo/Somos_um_em_Cristo_apresentacao.pptx
+++ b/aula-somos-um-em-cristo/Somos_um_em_Cristo_apresentacao.pptx
@@ -3205,8 +3205,8 @@
         </p:nvSpPr>
         <p:spPr>
           <a:xfrm>
-            <a:off x="0" y="2331720"/>
-            <a:ext cx="12191695" cy="54864"/>
+            <a:off x="0" y="2286000"/>
+            <a:ext cx="12191695" cy="64008"/>
           </a:xfrm>
           <a:prstGeom prst="rect">
             <a:avLst/>
@@ -3249,8 +3249,8 @@
         </p:nvSpPr>
         <p:spPr>
           <a:xfrm>
-            <a:off x="0" y="4892040"/>
-            <a:ext cx="12191695" cy="54864"/>
+            <a:off x="0" y="4983480"/>
+            <a:ext cx="12191695" cy="64008"/>
           </a:xfrm>
           <a:prstGeom prst="rect">
             <a:avLst/>
@@ -3293,7 +3293,7 @@
         </p:nvSpPr>
         <p:spPr>
           <a:xfrm>
-            <a:off x="731520" y="640080"/>
+            <a:off x="731520" y="594360"/>
             <a:ext cx="10698480" cy="548640"/>
           </a:xfrm>
           <a:prstGeom prst="rect">
@@ -3316,7 +3316,7 @@
               </a:spcAft>
             </a:pPr>
             <a:r>
-              <a:rPr sz="1600" b="1" i="0">
+              <a:rPr sz="1800" b="1" i="0">
                 <a:solidFill>
                   <a:srgbClr val="C9A227"/>
                 </a:solidFill>
@@ -3335,8 +3335,8 @@
         </p:nvSpPr>
         <p:spPr>
           <a:xfrm>
-            <a:off x="731520" y="2468880"/>
-            <a:ext cx="10698480" cy="1828800"/>
+            <a:off x="548640" y="2423160"/>
+            <a:ext cx="11064240" cy="1828800"/>
           </a:xfrm>
           <a:prstGeom prst="rect">
             <a:avLst/>
@@ -3358,7 +3358,7 @@
               </a:spcAft>
             </a:pPr>
             <a:r>
-              <a:rPr sz="6000" b="1" i="0">
+              <a:rPr sz="6400" b="1" i="0">
                 <a:solidFill>
                   <a:srgbClr val="FFFFFF"/>
                 </a:solidFill>
@@ -3377,7 +3377,7 @@
         </p:nvSpPr>
         <p:spPr>
           <a:xfrm>
-            <a:off x="731520" y="4114800"/>
+            <a:off x="731520" y="4160520"/>
             <a:ext cx="10698480" cy="731520"/>
           </a:xfrm>
           <a:prstGeom prst="rect">
@@ -3400,7 +3400,7 @@
               </a:spcAft>
             </a:pPr>
             <a:r>
-              <a:rPr sz="2200" b="0" i="1">
+              <a:rPr sz="2600" b="0" i="1">
                 <a:solidFill>
                   <a:srgbClr val="F6F2E8"/>
                 </a:solidFill>
@@ -3419,7 +3419,7 @@
         </p:nvSpPr>
         <p:spPr>
           <a:xfrm>
-            <a:off x="731520" y="5029200"/>
+            <a:off x="731520" y="5120640"/>
             <a:ext cx="10698480" cy="548640"/>
           </a:xfrm>
           <a:prstGeom prst="rect">
@@ -3442,7 +3442,7 @@
               </a:spcAft>
             </a:pPr>
             <a:r>
-              <a:rPr sz="1800" b="1" i="0">
+              <a:rPr sz="2200" b="1" i="0">
                 <a:solidFill>
                   <a:srgbClr val="C9A227"/>
                 </a:solidFill>
@@ -3461,7 +3461,7 @@
         </p:nvSpPr>
         <p:spPr>
           <a:xfrm>
-            <a:off x="731520" y="6035040"/>
+            <a:off x="731520" y="6080760"/>
             <a:ext cx="10698480" cy="457200"/>
           </a:xfrm>
           <a:prstGeom prst="rect">
@@ -3484,7 +3484,7 @@
               </a:spcAft>
             </a:pPr>
             <a:r>
-              <a:rPr sz="1400" b="0" i="0">
+              <a:rPr sz="1600" b="0" i="0">
                 <a:solidFill>
                   <a:srgbClr val="F6F2E8"/>
                 </a:solidFill>
@@ -3566,7 +3566,7 @@
         <p:spPr>
           <a:xfrm>
             <a:off x="0" y="0"/>
-            <a:ext cx="12191695" cy="1143000"/>
+            <a:ext cx="12191695" cy="1188720"/>
           </a:xfrm>
           <a:prstGeom prst="rect">
             <a:avLst/>
@@ -3609,8 +3609,8 @@
         </p:nvSpPr>
         <p:spPr>
           <a:xfrm>
-            <a:off x="0" y="1143000"/>
-            <a:ext cx="12191695" cy="73152"/>
+            <a:off x="0" y="1188720"/>
+            <a:ext cx="12191695" cy="82296"/>
           </a:xfrm>
           <a:prstGeom prst="rect">
             <a:avLst/>
@@ -3653,7 +3653,7 @@
         </p:nvSpPr>
         <p:spPr>
           <a:xfrm>
-            <a:off x="548640" y="256032"/>
+            <a:off x="548640" y="201168"/>
             <a:ext cx="11064240" cy="868680"/>
           </a:xfrm>
           <a:prstGeom prst="rect">
@@ -3676,13 +3676,13 @@
               </a:spcAft>
             </a:pPr>
             <a:r>
-              <a:rPr sz="3000" b="1" i="0">
+              <a:rPr sz="3400" b="1" i="0">
                 <a:solidFill>
                   <a:srgbClr val="FFFFFF"/>
                 </a:solidFill>
                 <a:latin typeface="Georgia"/>
               </a:rPr>
-              <a:t>A base da unidade: vidas transformadas</a:t>
+              <a:t>A base: vidas transformadas</a:t>
             </a:r>
           </a:p>
         </p:txBody>
@@ -3695,8 +3695,8 @@
         </p:nvSpPr>
         <p:spPr>
           <a:xfrm>
-            <a:off x="548640" y="841248"/>
-            <a:ext cx="11064240" cy="320040"/>
+            <a:off x="566928" y="868680"/>
+            <a:ext cx="11064240" cy="365760"/>
           </a:xfrm>
           <a:prstGeom prst="rect">
             <a:avLst/>
@@ -3718,7 +3718,7 @@
               </a:spcAft>
             </a:pPr>
             <a:r>
-              <a:rPr sz="1500" b="1" i="1">
+              <a:rPr sz="1800" b="1" i="1">
                 <a:solidFill>
                   <a:srgbClr val="C9A227"/>
                 </a:solidFill>
@@ -3737,8 +3737,8 @@
         </p:nvSpPr>
         <p:spPr>
           <a:xfrm>
-            <a:off x="822960" y="1508760"/>
-            <a:ext cx="10515600" cy="2011680"/>
+            <a:off x="822960" y="1554480"/>
+            <a:ext cx="10607040" cy="2194560"/>
           </a:xfrm>
           <a:prstGeom prst="rect">
             <a:avLst/>
@@ -3753,33 +3753,33 @@
           <a:p>
             <a:pPr>
               <a:spcAft>
-                <a:spcPts val="1000"/>
-              </a:spcAft>
-            </a:pPr>
-            <a:r>
-              <a:rPr sz="2000" b="0" i="0">
+                <a:spcPts val="1400"/>
+              </a:spcAft>
+            </a:pPr>
+            <a:r>
+              <a:rPr sz="2600" b="0" i="0">
                 <a:solidFill>
                   <a:srgbClr val="2B2B2B"/>
                 </a:solidFill>
                 <a:latin typeface="Calibri"/>
               </a:rPr>
-              <a:t>• Relacionamento com Deus primeiro: oferecer o corpo em sacrifício vivo, santo e agradável — nosso culto racional.</a:t>
+              <a:t>• Primeiro, o relacionamento com Deus: oferecer o corpo em sacrifício vivo, santo e agradável — nosso culto racional.</a:t>
             </a:r>
           </a:p>
           <a:p>
             <a:pPr>
               <a:spcAft>
-                <a:spcPts val="1000"/>
-              </a:spcAft>
-            </a:pPr>
-            <a:r>
-              <a:rPr sz="2000" b="0" i="0">
+                <a:spcPts val="1400"/>
+              </a:spcAft>
+            </a:pPr>
+            <a:r>
+              <a:rPr sz="2600" b="0" i="0">
                 <a:solidFill>
                   <a:srgbClr val="2B2B2B"/>
                 </a:solidFill>
                 <a:latin typeface="Calibri"/>
               </a:rPr>
-              <a:t>• Não se conformar com este mundo, mas ser transformado pela renovação da mente (gr. metamorfose: mudança de dentro para fora).</a:t>
+              <a:t>• Não se conformar com este mundo, mas transformar-se pela renovação da mente (gr.: metamorfose, de dentro para fora).</a:t>
             </a:r>
           </a:p>
         </p:txBody>
@@ -3792,7 +3792,7 @@
         </p:nvSpPr>
         <p:spPr>
           <a:xfrm>
-            <a:off x="822960" y="4114800"/>
+            <a:off x="822960" y="4480560"/>
             <a:ext cx="10515600" cy="1554480"/>
           </a:xfrm>
           <a:prstGeom prst="roundRect">
@@ -3823,7 +3823,7 @@
           </a:fontRef>
         </p:style>
         <p:txBody>
-          <a:bodyPr rtlCol="0" anchor="ctr" wrap="square" lIns="365760" rIns="320040"/>
+          <a:bodyPr rtlCol="0" anchor="ctr" wrap="square" lIns="411480" rIns="365760"/>
           <a:lstStyle/>
           <a:p>
             <a:pPr algn="l">
@@ -3835,13 +3835,13 @@
               </a:spcAft>
             </a:pPr>
             <a:r>
-              <a:rPr sz="1900" b="0" i="1">
+              <a:rPr sz="2300" b="0" i="1">
                 <a:solidFill>
                   <a:srgbClr val="162A45"/>
                 </a:solidFill>
                 <a:latin typeface="Georgia"/>
               </a:rPr>
-              <a:t>“Rogo-vos... que apresenteis o vosso corpo por sacrifício vivo... Transformai-vos pela renovação da vossa mente.”</a:t>
+              <a:t>“Apresentai o vosso corpo por sacrifício vivo... transformai-vos pela renovação da vossa mente.”</a:t>
             </a:r>
           </a:p>
           <a:p>
@@ -3854,7 +3854,7 @@
               </a:spcAft>
             </a:pPr>
             <a:r>
-              <a:rPr sz="1500" b="1" i="0">
+              <a:rPr sz="1900" b="1" i="0">
                 <a:solidFill>
                   <a:srgbClr val="2E6E6A"/>
                 </a:solidFill>
@@ -3873,8 +3873,8 @@
         </p:nvSpPr>
         <p:spPr>
           <a:xfrm>
-            <a:off x="822960" y="4114800"/>
-            <a:ext cx="118872" cy="1554480"/>
+            <a:off x="822960" y="4480560"/>
+            <a:ext cx="137160" cy="1554480"/>
           </a:xfrm>
           <a:prstGeom prst="rect">
             <a:avLst/>
@@ -3940,7 +3940,7 @@
               </a:spcAft>
             </a:pPr>
             <a:r>
-              <a:rPr sz="1100" b="0" i="0">
+              <a:rPr sz="1200" b="0" i="0">
                 <a:solidFill>
                   <a:srgbClr val="1F3A5F"/>
                 </a:solidFill>
@@ -3959,8 +3959,8 @@
         </p:nvSpPr>
         <p:spPr>
           <a:xfrm>
-            <a:off x="11338560" y="6400800"/>
-            <a:ext cx="731520" cy="365760"/>
+            <a:off x="11247120" y="6400800"/>
+            <a:ext cx="822960" cy="365760"/>
           </a:xfrm>
           <a:prstGeom prst="rect">
             <a:avLst/>
@@ -3982,7 +3982,7 @@
               </a:spcAft>
             </a:pPr>
             <a:r>
-              <a:rPr sz="1100" b="0" i="0">
+              <a:rPr sz="1200" b="0" i="0">
                 <a:solidFill>
                   <a:srgbClr val="1F3A5F"/>
                 </a:solidFill>
@@ -4064,7 +4064,7 @@
         <p:spPr>
           <a:xfrm>
             <a:off x="0" y="0"/>
-            <a:ext cx="12191695" cy="1143000"/>
+            <a:ext cx="12191695" cy="1188720"/>
           </a:xfrm>
           <a:prstGeom prst="rect">
             <a:avLst/>
@@ -4107,8 +4107,8 @@
         </p:nvSpPr>
         <p:spPr>
           <a:xfrm>
-            <a:off x="0" y="1143000"/>
-            <a:ext cx="12191695" cy="73152"/>
+            <a:off x="0" y="1188720"/>
+            <a:ext cx="12191695" cy="82296"/>
           </a:xfrm>
           <a:prstGeom prst="rect">
             <a:avLst/>
@@ -4151,7 +4151,7 @@
         </p:nvSpPr>
         <p:spPr>
           <a:xfrm>
-            <a:off x="548640" y="256032"/>
+            <a:off x="548640" y="201168"/>
             <a:ext cx="11064240" cy="868680"/>
           </a:xfrm>
           <a:prstGeom prst="rect">
@@ -4174,7 +4174,7 @@
               </a:spcAft>
             </a:pPr>
             <a:r>
-              <a:rPr sz="3000" b="1" i="0">
+              <a:rPr sz="3400" b="1" i="0">
                 <a:solidFill>
                   <a:srgbClr val="FFFFFF"/>
                 </a:solidFill>
@@ -4193,8 +4193,8 @@
         </p:nvSpPr>
         <p:spPr>
           <a:xfrm>
-            <a:off x="548640" y="841248"/>
-            <a:ext cx="11064240" cy="320040"/>
+            <a:off x="566928" y="868680"/>
+            <a:ext cx="11064240" cy="365760"/>
           </a:xfrm>
           <a:prstGeom prst="rect">
             <a:avLst/>
@@ -4216,7 +4216,7 @@
               </a:spcAft>
             </a:pPr>
             <a:r>
-              <a:rPr sz="1500" b="1" i="1">
+              <a:rPr sz="1800" b="1" i="1">
                 <a:solidFill>
                   <a:srgbClr val="C9A227"/>
                 </a:solidFill>
@@ -4235,8 +4235,8 @@
         </p:nvSpPr>
         <p:spPr>
           <a:xfrm>
-            <a:off x="640080" y="2011680"/>
-            <a:ext cx="2606040" cy="3108960"/>
+            <a:off x="640080" y="1920240"/>
+            <a:ext cx="2606040" cy="3383280"/>
           </a:xfrm>
           <a:prstGeom prst="roundRect">
             <a:avLst/>
@@ -4264,7 +4264,7 @@
           </a:fontRef>
         </p:style>
         <p:txBody>
-          <a:bodyPr rtlCol="0" anchor="ctr" wrap="square" lIns="182880" rIns="182880"/>
+          <a:bodyPr rtlCol="0" anchor="ctr" wrap="square" lIns="164592" rIns="164592"/>
           <a:lstStyle/>
           <a:p>
             <a:pPr algn="ctr">
@@ -4272,11 +4272,11 @@
                 <a:spcPts val="0"/>
               </a:spcBef>
               <a:spcAft>
-                <a:spcPts val="1000"/>
-              </a:spcAft>
-            </a:pPr>
-            <a:r>
-              <a:rPr sz="2200" b="1" i="0">
+                <a:spcPts val="1200"/>
+              </a:spcAft>
+            </a:pPr>
+            <a:r>
+              <a:rPr sz="2300" b="1" i="0">
                 <a:solidFill>
                   <a:srgbClr val="FFFFFF"/>
                 </a:solidFill>
@@ -4295,7 +4295,7 @@
               </a:spcAft>
             </a:pPr>
             <a:r>
-              <a:rPr sz="1500" b="0" i="0">
+              <a:rPr sz="1800" b="0" i="0">
                 <a:solidFill>
                   <a:srgbClr val="F6F2E8"/>
                 </a:solidFill>
@@ -4314,7 +4314,7 @@
               </a:spcAft>
             </a:pPr>
             <a:r>
-              <a:rPr sz="1500" b="0" i="0">
+              <a:rPr sz="1800" b="0" i="0">
                 <a:solidFill>
                   <a:srgbClr val="F6F2E8"/>
                 </a:solidFill>
@@ -4333,8 +4333,8 @@
         </p:nvSpPr>
         <p:spPr>
           <a:xfrm>
-            <a:off x="3429000" y="2011680"/>
-            <a:ext cx="2606040" cy="3108960"/>
+            <a:off x="3429000" y="1920240"/>
+            <a:ext cx="2606040" cy="3383280"/>
           </a:xfrm>
           <a:prstGeom prst="roundRect">
             <a:avLst/>
@@ -4362,7 +4362,7 @@
           </a:fontRef>
         </p:style>
         <p:txBody>
-          <a:bodyPr rtlCol="0" anchor="ctr" wrap="square" lIns="182880" rIns="182880"/>
+          <a:bodyPr rtlCol="0" anchor="ctr" wrap="square" lIns="164592" rIns="164592"/>
           <a:lstStyle/>
           <a:p>
             <a:pPr algn="ctr">
@@ -4370,11 +4370,11 @@
                 <a:spcPts val="0"/>
               </a:spcBef>
               <a:spcAft>
-                <a:spcPts val="1000"/>
-              </a:spcAft>
-            </a:pPr>
-            <a:r>
-              <a:rPr sz="2200" b="1" i="0">
+                <a:spcPts val="1200"/>
+              </a:spcAft>
+            </a:pPr>
+            <a:r>
+              <a:rPr sz="2300" b="1" i="0">
                 <a:solidFill>
                   <a:srgbClr val="FFFFFF"/>
                 </a:solidFill>
@@ -4393,7 +4393,7 @@
               </a:spcAft>
             </a:pPr>
             <a:r>
-              <a:rPr sz="1500" b="0" i="0">
+              <a:rPr sz="1800" b="0" i="0">
                 <a:solidFill>
                   <a:srgbClr val="F6F2E8"/>
                 </a:solidFill>
@@ -4412,7 +4412,7 @@
               </a:spcAft>
             </a:pPr>
             <a:r>
-              <a:rPr sz="1500" b="0" i="0">
+              <a:rPr sz="1800" b="0" i="0">
                 <a:solidFill>
                   <a:srgbClr val="F6F2E8"/>
                 </a:solidFill>
@@ -4431,7 +4431,7 @@
               </a:spcAft>
             </a:pPr>
             <a:r>
-              <a:rPr sz="1500" b="0" i="0">
+              <a:rPr sz="1800" b="0" i="0">
                 <a:solidFill>
                   <a:srgbClr val="F6F2E8"/>
                 </a:solidFill>
@@ -4450,8 +4450,8 @@
         </p:nvSpPr>
         <p:spPr>
           <a:xfrm>
-            <a:off x="6217920" y="2011680"/>
-            <a:ext cx="2606040" cy="3108960"/>
+            <a:off x="6217920" y="1920240"/>
+            <a:ext cx="2606040" cy="3383280"/>
           </a:xfrm>
           <a:prstGeom prst="roundRect">
             <a:avLst/>
@@ -4479,7 +4479,7 @@
           </a:fontRef>
         </p:style>
         <p:txBody>
-          <a:bodyPr rtlCol="0" anchor="ctr" wrap="square" lIns="182880" rIns="182880"/>
+          <a:bodyPr rtlCol="0" anchor="ctr" wrap="square" lIns="164592" rIns="164592"/>
           <a:lstStyle/>
           <a:p>
             <a:pPr algn="ctr">
@@ -4487,11 +4487,11 @@
                 <a:spcPts val="0"/>
               </a:spcBef>
               <a:spcAft>
-                <a:spcPts val="1000"/>
-              </a:spcAft>
-            </a:pPr>
-            <a:r>
-              <a:rPr sz="2200" b="1" i="0">
+                <a:spcPts val="1200"/>
+              </a:spcAft>
+            </a:pPr>
+            <a:r>
+              <a:rPr sz="2300" b="1" i="0">
                 <a:solidFill>
                   <a:srgbClr val="162A45"/>
                 </a:solidFill>
@@ -4510,7 +4510,7 @@
               </a:spcAft>
             </a:pPr>
             <a:r>
-              <a:rPr sz="1500" b="0" i="0">
+              <a:rPr sz="1800" b="0" i="0">
                 <a:solidFill>
                   <a:srgbClr val="162A45"/>
                 </a:solidFill>
@@ -4529,7 +4529,7 @@
               </a:spcAft>
             </a:pPr>
             <a:r>
-              <a:rPr sz="1500" b="0" i="0">
+              <a:rPr sz="1800" b="0" i="0">
                 <a:solidFill>
                   <a:srgbClr val="162A45"/>
                 </a:solidFill>
@@ -4548,7 +4548,7 @@
               </a:spcAft>
             </a:pPr>
             <a:r>
-              <a:rPr sz="1500" b="0" i="0">
+              <a:rPr sz="1800" b="0" i="0">
                 <a:solidFill>
                   <a:srgbClr val="162A45"/>
                 </a:solidFill>
@@ -4567,8 +4567,8 @@
         </p:nvSpPr>
         <p:spPr>
           <a:xfrm>
-            <a:off x="9006840" y="2011680"/>
-            <a:ext cx="2606040" cy="3108960"/>
+            <a:off x="9006840" y="1920240"/>
+            <a:ext cx="2606040" cy="3383280"/>
           </a:xfrm>
           <a:prstGeom prst="roundRect">
             <a:avLst/>
@@ -4596,7 +4596,7 @@
           </a:fontRef>
         </p:style>
         <p:txBody>
-          <a:bodyPr rtlCol="0" anchor="ctr" wrap="square" lIns="182880" rIns="182880"/>
+          <a:bodyPr rtlCol="0" anchor="ctr" wrap="square" lIns="164592" rIns="164592"/>
           <a:lstStyle/>
           <a:p>
             <a:pPr algn="ctr">
@@ -4604,11 +4604,11 @@
                 <a:spcPts val="0"/>
               </a:spcBef>
               <a:spcAft>
-                <a:spcPts val="1000"/>
-              </a:spcAft>
-            </a:pPr>
-            <a:r>
-              <a:rPr sz="2200" b="1" i="0">
+                <a:spcPts val="1200"/>
+              </a:spcAft>
+            </a:pPr>
+            <a:r>
+              <a:rPr sz="2300" b="1" i="0">
                 <a:solidFill>
                   <a:srgbClr val="FFFFFF"/>
                 </a:solidFill>
@@ -4627,7 +4627,7 @@
               </a:spcAft>
             </a:pPr>
             <a:r>
-              <a:rPr sz="1500" b="0" i="0">
+              <a:rPr sz="1800" b="0" i="0">
                 <a:solidFill>
                   <a:srgbClr val="F6F2E8"/>
                 </a:solidFill>
@@ -4646,7 +4646,7 @@
               </a:spcAft>
             </a:pPr>
             <a:r>
-              <a:rPr sz="1500" b="0" i="0">
+              <a:rPr sz="1800" b="0" i="0">
                 <a:solidFill>
                   <a:srgbClr val="F6F2E8"/>
                 </a:solidFill>
@@ -4665,7 +4665,7 @@
               </a:spcAft>
             </a:pPr>
             <a:r>
-              <a:rPr sz="1500" b="0" i="0">
+              <a:rPr sz="1800" b="0" i="0">
                 <a:solidFill>
                   <a:srgbClr val="F6F2E8"/>
                 </a:solidFill>
@@ -4707,7 +4707,7 @@
               </a:spcAft>
             </a:pPr>
             <a:r>
-              <a:rPr sz="1100" b="0" i="0">
+              <a:rPr sz="1200" b="0" i="0">
                 <a:solidFill>
                   <a:srgbClr val="1F3A5F"/>
                 </a:solidFill>
@@ -4726,8 +4726,8 @@
         </p:nvSpPr>
         <p:spPr>
           <a:xfrm>
-            <a:off x="11338560" y="6400800"/>
-            <a:ext cx="731520" cy="365760"/>
+            <a:off x="11247120" y="6400800"/>
+            <a:ext cx="822960" cy="365760"/>
           </a:xfrm>
           <a:prstGeom prst="rect">
             <a:avLst/>
@@ -4749,7 +4749,7 @@
               </a:spcAft>
             </a:pPr>
             <a:r>
-              <a:rPr sz="1100" b="0" i="0">
+              <a:rPr sz="1200" b="0" i="0">
                 <a:solidFill>
                   <a:srgbClr val="1F3A5F"/>
                 </a:solidFill>
@@ -4831,7 +4831,7 @@
         <p:spPr>
           <a:xfrm>
             <a:off x="0" y="0"/>
-            <a:ext cx="12191695" cy="1143000"/>
+            <a:ext cx="12191695" cy="1188720"/>
           </a:xfrm>
           <a:prstGeom prst="rect">
             <a:avLst/>
@@ -4874,8 +4874,8 @@
         </p:nvSpPr>
         <p:spPr>
           <a:xfrm>
-            <a:off x="0" y="1143000"/>
-            <a:ext cx="12191695" cy="73152"/>
+            <a:off x="0" y="1188720"/>
+            <a:ext cx="12191695" cy="82296"/>
           </a:xfrm>
           <a:prstGeom prst="rect">
             <a:avLst/>
@@ -4918,7 +4918,7 @@
         </p:nvSpPr>
         <p:spPr>
           <a:xfrm>
-            <a:off x="548640" y="256032"/>
+            <a:off x="548640" y="201168"/>
             <a:ext cx="11064240" cy="868680"/>
           </a:xfrm>
           <a:prstGeom prst="rect">
@@ -4941,7 +4941,7 @@
               </a:spcAft>
             </a:pPr>
             <a:r>
-              <a:rPr sz="3000" b="1" i="0">
+              <a:rPr sz="3400" b="1" i="0">
                 <a:solidFill>
                   <a:srgbClr val="FFFFFF"/>
                 </a:solidFill>
@@ -4960,8 +4960,8 @@
         </p:nvSpPr>
         <p:spPr>
           <a:xfrm>
-            <a:off x="548640" y="841248"/>
-            <a:ext cx="11064240" cy="320040"/>
+            <a:off x="566928" y="868680"/>
+            <a:ext cx="11064240" cy="365760"/>
           </a:xfrm>
           <a:prstGeom prst="rect">
             <a:avLst/>
@@ -4983,7 +4983,7 @@
               </a:spcAft>
             </a:pPr>
             <a:r>
-              <a:rPr sz="1500" b="1" i="1">
+              <a:rPr sz="1800" b="1" i="1">
                 <a:solidFill>
                   <a:srgbClr val="C9A227"/>
                 </a:solidFill>
@@ -5002,8 +5002,8 @@
         </p:nvSpPr>
         <p:spPr>
           <a:xfrm>
-            <a:off x="822960" y="1554480"/>
-            <a:ext cx="10515600" cy="4572000"/>
+            <a:off x="822960" y="1600200"/>
+            <a:ext cx="10607040" cy="4572000"/>
           </a:xfrm>
           <a:prstGeom prst="rect">
             <a:avLst/>
@@ -5022,45 +5022,45 @@
               </a:spcAft>
             </a:pPr>
             <a:r>
-              <a:rPr sz="2100" b="1" i="0">
+              <a:rPr sz="2800" b="1" i="0">
                 <a:solidFill>
                   <a:srgbClr val="1F3A5F"/>
                 </a:solidFill>
                 <a:latin typeface="Calibri"/>
               </a:rPr>
-              <a:t>• “Somos um só corpo.” Fazemos parte de uma só família, somos um só rebanho.</a:t>
+              <a:t>• “Somos um só corpo.” Uma só família, um só rebanho.</a:t>
             </a:r>
           </a:p>
           <a:p>
             <a:pPr>
               <a:spcAft>
-                <a:spcPts val="1200"/>
-              </a:spcAft>
-            </a:pPr>
-            <a:r>
-              <a:rPr sz="2000" b="0" i="0">
+                <a:spcPts val="1400"/>
+              </a:spcAft>
+            </a:pPr>
+            <a:r>
+              <a:rPr sz="2600" b="0" i="0">
                 <a:solidFill>
                   <a:srgbClr val="2B2B2B"/>
                 </a:solidFill>
                 <a:latin typeface="Calibri"/>
               </a:rPr>
-              <a:t>• O que dá unidade ao corpo é estarmos ligados à mesma Cabeça — Cristo — e sermos irrigados pelo mesmo sangue.</a:t>
+              <a:t>• O que dá unidade ao corpo é estarmos ligados à mesma Cabeça — Cristo — e irrigados pelo mesmo sangue.</a:t>
             </a:r>
           </a:p>
           <a:p>
             <a:pPr>
               <a:spcAft>
-                <a:spcPts val="1000"/>
-              </a:spcAft>
-            </a:pPr>
-            <a:r>
-              <a:rPr sz="2000" b="0" i="0">
+                <a:spcPts val="1400"/>
+              </a:spcAft>
+            </a:pPr>
+            <a:r>
+              <a:rPr sz="2600" b="0" i="0">
                 <a:solidFill>
                   <a:srgbClr val="2B2B2B"/>
                 </a:solidFill>
                 <a:latin typeface="Calibri"/>
               </a:rPr>
-              <a:t>• A unidade não é algo que produzimos; é algo que recebemos. Já somos um em Cristo — cabe-nos guardar essa unidade.</a:t>
+              <a:t>• A unidade não é algo que produzimos; é algo que recebemos. Já somos um em Cristo — cabe-nos guardá-la.</a:t>
             </a:r>
           </a:p>
         </p:txBody>
@@ -5096,7 +5096,7 @@
               </a:spcAft>
             </a:pPr>
             <a:r>
-              <a:rPr sz="1100" b="0" i="0">
+              <a:rPr sz="1200" b="0" i="0">
                 <a:solidFill>
                   <a:srgbClr val="1F3A5F"/>
                 </a:solidFill>
@@ -5115,8 +5115,8 @@
         </p:nvSpPr>
         <p:spPr>
           <a:xfrm>
-            <a:off x="11338560" y="6400800"/>
-            <a:ext cx="731520" cy="365760"/>
+            <a:off x="11247120" y="6400800"/>
+            <a:ext cx="822960" cy="365760"/>
           </a:xfrm>
           <a:prstGeom prst="rect">
             <a:avLst/>
@@ -5138,7 +5138,7 @@
               </a:spcAft>
             </a:pPr>
             <a:r>
-              <a:rPr sz="1100" b="0" i="0">
+              <a:rPr sz="1200" b="0" i="0">
                 <a:solidFill>
                   <a:srgbClr val="1F3A5F"/>
                 </a:solidFill>
@@ -5220,7 +5220,7 @@
         <p:spPr>
           <a:xfrm>
             <a:off x="0" y="0"/>
-            <a:ext cx="12191695" cy="1143000"/>
+            <a:ext cx="12191695" cy="1188720"/>
           </a:xfrm>
           <a:prstGeom prst="rect">
             <a:avLst/>
@@ -5263,8 +5263,8 @@
         </p:nvSpPr>
         <p:spPr>
           <a:xfrm>
-            <a:off x="0" y="1143000"/>
-            <a:ext cx="12191695" cy="73152"/>
+            <a:off x="0" y="1188720"/>
+            <a:ext cx="12191695" cy="82296"/>
           </a:xfrm>
           <a:prstGeom prst="rect">
             <a:avLst/>
@@ -5307,7 +5307,7 @@
         </p:nvSpPr>
         <p:spPr>
           <a:xfrm>
-            <a:off x="548640" y="256032"/>
+            <a:off x="548640" y="201168"/>
             <a:ext cx="11064240" cy="868680"/>
           </a:xfrm>
           <a:prstGeom prst="rect">
@@ -5330,7 +5330,7 @@
               </a:spcAft>
             </a:pPr>
             <a:r>
-              <a:rPr sz="3000" b="1" i="0">
+              <a:rPr sz="3400" b="1" i="0">
                 <a:solidFill>
                   <a:srgbClr val="FFFFFF"/>
                 </a:solidFill>
@@ -5349,8 +5349,8 @@
         </p:nvSpPr>
         <p:spPr>
           <a:xfrm>
-            <a:off x="548640" y="841248"/>
-            <a:ext cx="11064240" cy="320040"/>
+            <a:off x="566928" y="868680"/>
+            <a:ext cx="11064240" cy="365760"/>
           </a:xfrm>
           <a:prstGeom prst="rect">
             <a:avLst/>
@@ -5372,7 +5372,7 @@
               </a:spcAft>
             </a:pPr>
             <a:r>
-              <a:rPr sz="1500" b="1" i="1">
+              <a:rPr sz="1800" b="1" i="1">
                 <a:solidFill>
                   <a:srgbClr val="C9A227"/>
                 </a:solidFill>
@@ -5391,8 +5391,8 @@
         </p:nvSpPr>
         <p:spPr>
           <a:xfrm>
-            <a:off x="822960" y="1554480"/>
-            <a:ext cx="10515600" cy="4572000"/>
+            <a:off x="822960" y="1600200"/>
+            <a:ext cx="10607040" cy="4572000"/>
           </a:xfrm>
           <a:prstGeom prst="rect">
             <a:avLst/>
@@ -5411,39 +5411,39 @@
               </a:spcAft>
             </a:pPr>
             <a:r>
-              <a:rPr sz="2100" b="1" i="0">
+              <a:rPr sz="2800" b="1" i="0">
                 <a:solidFill>
                   <a:srgbClr val="2E6E6A"/>
                 </a:solidFill>
                 <a:latin typeface="Calibri"/>
               </a:rPr>
-              <a:t>• “Nem todos os membros têm a mesma função.” A marca das obras de Deus é a uniformidade dentro da unidade.</a:t>
+              <a:t>• “Nem todos os membros têm a mesma função.”</a:t>
             </a:r>
           </a:p>
           <a:p>
             <a:pPr>
               <a:spcAft>
-                <a:spcPts val="1200"/>
-              </a:spcAft>
-            </a:pPr>
-            <a:r>
-              <a:rPr sz="2000" b="0" i="0">
+                <a:spcPts val="1400"/>
+              </a:spcAft>
+            </a:pPr>
+            <a:r>
+              <a:rPr sz="2600" b="0" i="0">
                 <a:solidFill>
                   <a:srgbClr val="2B2B2B"/>
                 </a:solidFill>
                 <a:latin typeface="Calibri"/>
               </a:rPr>
-              <a:t>• Homens e mulheres das mais diversas origens, ambientes e temperamentos são dotados por Deus de grande variedade de dons.</a:t>
+              <a:t>• Pessoas das mais diversas origens, ambientes e temperamentos são dotadas por Deus de grande variedade de dons.</a:t>
             </a:r>
           </a:p>
           <a:p>
             <a:pPr>
               <a:spcAft>
-                <a:spcPts val="1000"/>
-              </a:spcAft>
-            </a:pPr>
-            <a:r>
-              <a:rPr sz="2000" b="0" i="0">
+                <a:spcPts val="1400"/>
+              </a:spcAft>
+            </a:pPr>
+            <a:r>
+              <a:rPr sz="2600" b="0" i="0">
                 <a:solidFill>
                   <a:srgbClr val="2B2B2B"/>
                 </a:solidFill>
@@ -5485,7 +5485,7 @@
               </a:spcAft>
             </a:pPr>
             <a:r>
-              <a:rPr sz="1100" b="0" i="0">
+              <a:rPr sz="1200" b="0" i="0">
                 <a:solidFill>
                   <a:srgbClr val="1F3A5F"/>
                 </a:solidFill>
@@ -5504,8 +5504,8 @@
         </p:nvSpPr>
         <p:spPr>
           <a:xfrm>
-            <a:off x="11338560" y="6400800"/>
-            <a:ext cx="731520" cy="365760"/>
+            <a:off x="11247120" y="6400800"/>
+            <a:ext cx="822960" cy="365760"/>
           </a:xfrm>
           <a:prstGeom prst="rect">
             <a:avLst/>
@@ -5527,7 +5527,7 @@
               </a:spcAft>
             </a:pPr>
             <a:r>
-              <a:rPr sz="1100" b="0" i="0">
+              <a:rPr sz="1200" b="0" i="0">
                 <a:solidFill>
                   <a:srgbClr val="1F3A5F"/>
                 </a:solidFill>
@@ -5609,7 +5609,7 @@
         <p:spPr>
           <a:xfrm>
             <a:off x="0" y="0"/>
-            <a:ext cx="12191695" cy="1143000"/>
+            <a:ext cx="12191695" cy="1188720"/>
           </a:xfrm>
           <a:prstGeom prst="rect">
             <a:avLst/>
@@ -5652,8 +5652,8 @@
         </p:nvSpPr>
         <p:spPr>
           <a:xfrm>
-            <a:off x="0" y="1143000"/>
-            <a:ext cx="12191695" cy="73152"/>
+            <a:off x="0" y="1188720"/>
+            <a:ext cx="12191695" cy="82296"/>
           </a:xfrm>
           <a:prstGeom prst="rect">
             <a:avLst/>
@@ -5696,7 +5696,7 @@
         </p:nvSpPr>
         <p:spPr>
           <a:xfrm>
-            <a:off x="548640" y="256032"/>
+            <a:off x="548640" y="201168"/>
             <a:ext cx="11064240" cy="868680"/>
           </a:xfrm>
           <a:prstGeom prst="rect">
@@ -5719,7 +5719,7 @@
               </a:spcAft>
             </a:pPr>
             <a:r>
-              <a:rPr sz="3000" b="1" i="0">
+              <a:rPr sz="3400" b="1" i="0">
                 <a:solidFill>
                   <a:srgbClr val="FFFFFF"/>
                 </a:solidFill>
@@ -5738,8 +5738,8 @@
         </p:nvSpPr>
         <p:spPr>
           <a:xfrm>
-            <a:off x="548640" y="841248"/>
-            <a:ext cx="11064240" cy="320040"/>
+            <a:off x="566928" y="868680"/>
+            <a:ext cx="11064240" cy="365760"/>
           </a:xfrm>
           <a:prstGeom prst="rect">
             <a:avLst/>
@@ -5761,7 +5761,7 @@
               </a:spcAft>
             </a:pPr>
             <a:r>
-              <a:rPr sz="1500" b="1" i="1">
+              <a:rPr sz="1800" b="1" i="1">
                 <a:solidFill>
                   <a:srgbClr val="C9A227"/>
                 </a:solidFill>
@@ -5780,8 +5780,8 @@
         </p:nvSpPr>
         <p:spPr>
           <a:xfrm>
-            <a:off x="822960" y="1554480"/>
-            <a:ext cx="10515600" cy="4572000"/>
+            <a:off x="822960" y="1600200"/>
+            <a:ext cx="10607040" cy="4572000"/>
           </a:xfrm>
           <a:prstGeom prst="rect">
             <a:avLst/>
@@ -5800,39 +5800,39 @@
               </a:spcAft>
             </a:pPr>
             <a:r>
-              <a:rPr sz="2100" b="1" i="0">
+              <a:rPr sz="2800" b="1" i="0">
                 <a:solidFill>
                   <a:srgbClr val="C9A227"/>
                 </a:solidFill>
                 <a:latin typeface="Calibri"/>
               </a:rPr>
-              <a:t>• “Somos membros uns dos outros.” Não estamos competindo — estamos servindo uns aos outros.</a:t>
+              <a:t>• “Somos membros uns dos outros.”</a:t>
             </a:r>
           </a:p>
           <a:p>
             <a:pPr>
               <a:spcAft>
-                <a:spcPts val="1200"/>
-              </a:spcAft>
-            </a:pPr>
-            <a:r>
-              <a:rPr sz="2000" b="0" i="0">
+                <a:spcPts val="1400"/>
+              </a:spcAft>
+            </a:pPr>
+            <a:r>
+              <a:rPr sz="2600" b="0" i="0">
                 <a:solidFill>
                   <a:srgbClr val="2B2B2B"/>
                 </a:solidFill>
                 <a:latin typeface="Calibri"/>
               </a:rPr>
-              <a:t>• Como as mãos levam o alimento à boca: os membros trabalham para a edificação do corpo, com igual cuidado uns pelos outros (1Co 12.25).</a:t>
+              <a:t>• Não estamos competindo — estamos servindo uns aos outros, com igual cuidado uns pelos outros (1Co 12.25).</a:t>
             </a:r>
           </a:p>
           <a:p>
             <a:pPr>
               <a:spcAft>
-                <a:spcPts val="1000"/>
-              </a:spcAft>
-            </a:pPr>
-            <a:r>
-              <a:rPr sz="2000" b="0" i="0">
+                <a:spcPts val="1400"/>
+              </a:spcAft>
+            </a:pPr>
+            <a:r>
+              <a:rPr sz="2600" b="0" i="0">
                 <a:solidFill>
                   <a:srgbClr val="2B2B2B"/>
                 </a:solidFill>
@@ -5874,7 +5874,7 @@
               </a:spcAft>
             </a:pPr>
             <a:r>
-              <a:rPr sz="1100" b="0" i="0">
+              <a:rPr sz="1200" b="0" i="0">
                 <a:solidFill>
                   <a:srgbClr val="1F3A5F"/>
                 </a:solidFill>
@@ -5893,8 +5893,8 @@
         </p:nvSpPr>
         <p:spPr>
           <a:xfrm>
-            <a:off x="11338560" y="6400800"/>
-            <a:ext cx="731520" cy="365760"/>
+            <a:off x="11247120" y="6400800"/>
+            <a:ext cx="822960" cy="365760"/>
           </a:xfrm>
           <a:prstGeom prst="rect">
             <a:avLst/>
@@ -5916,7 +5916,7 @@
               </a:spcAft>
             </a:pPr>
             <a:r>
-              <a:rPr sz="1100" b="0" i="0">
+              <a:rPr sz="1200" b="0" i="0">
                 <a:solidFill>
                   <a:srgbClr val="1F3A5F"/>
                 </a:solidFill>
@@ -5998,7 +5998,7 @@
         <p:spPr>
           <a:xfrm>
             <a:off x="0" y="0"/>
-            <a:ext cx="12191695" cy="1143000"/>
+            <a:ext cx="12191695" cy="1188720"/>
           </a:xfrm>
           <a:prstGeom prst="rect">
             <a:avLst/>
@@ -6041,8 +6041,8 @@
         </p:nvSpPr>
         <p:spPr>
           <a:xfrm>
-            <a:off x="0" y="1143000"/>
-            <a:ext cx="12191695" cy="73152"/>
+            <a:off x="0" y="1188720"/>
+            <a:ext cx="12191695" cy="82296"/>
           </a:xfrm>
           <a:prstGeom prst="rect">
             <a:avLst/>
@@ -6085,7 +6085,7 @@
         </p:nvSpPr>
         <p:spPr>
           <a:xfrm>
-            <a:off x="548640" y="256032"/>
+            <a:off x="548640" y="201168"/>
             <a:ext cx="11064240" cy="868680"/>
           </a:xfrm>
           <a:prstGeom prst="rect">
@@ -6108,7 +6108,7 @@
               </a:spcAft>
             </a:pPr>
             <a:r>
-              <a:rPr sz="3000" b="1" i="0">
+              <a:rPr sz="3400" b="1" i="0">
                 <a:solidFill>
                   <a:srgbClr val="FFFFFF"/>
                 </a:solidFill>
@@ -6127,8 +6127,8 @@
         </p:nvSpPr>
         <p:spPr>
           <a:xfrm>
-            <a:off x="548640" y="841248"/>
-            <a:ext cx="11064240" cy="320040"/>
+            <a:off x="566928" y="868680"/>
+            <a:ext cx="11064240" cy="365760"/>
           </a:xfrm>
           <a:prstGeom prst="rect">
             <a:avLst/>
@@ -6150,7 +6150,7 @@
               </a:spcAft>
             </a:pPr>
             <a:r>
-              <a:rPr sz="1500" b="1" i="1">
+              <a:rPr sz="1800" b="1" i="1">
                 <a:solidFill>
                   <a:srgbClr val="C9A227"/>
                 </a:solidFill>
@@ -6170,7 +6170,7 @@
         <p:spPr>
           <a:xfrm>
             <a:off x="822960" y="1463040"/>
-            <a:ext cx="10515600" cy="914400"/>
+            <a:ext cx="10607040" cy="822960"/>
           </a:xfrm>
           <a:prstGeom prst="rect">
             <a:avLst/>
@@ -6185,17 +6185,17 @@
           <a:p>
             <a:pPr>
               <a:spcAft>
-                <a:spcPts val="600"/>
-              </a:spcAft>
-            </a:pPr>
-            <a:r>
-              <a:rPr sz="2000" b="1" i="0">
+                <a:spcPts val="800"/>
+              </a:spcAft>
+            </a:pPr>
+            <a:r>
+              <a:rPr sz="2600" b="1" i="0">
                 <a:solidFill>
                   <a:srgbClr val="1F3A5F"/>
                 </a:solidFill>
                 <a:latin typeface="Calibri"/>
               </a:rPr>
-              <a:t>• Os dons são dados pela Trindade para a edificação do corpo — nenhum para exibição própria:</a:t>
+              <a:t>• Os dons são dados pela Trindade para edificar o corpo — nenhum para exibição própria:</a:t>
             </a:r>
           </a:p>
         </p:txBody>
@@ -6208,8 +6208,8 @@
         </p:nvSpPr>
         <p:spPr>
           <a:xfrm>
-            <a:off x="822960" y="2286000"/>
-            <a:ext cx="10515600" cy="3840480"/>
+            <a:off x="1005840" y="2423160"/>
+            <a:ext cx="10424160" cy="3840480"/>
           </a:xfrm>
           <a:prstGeom prst="rect">
             <a:avLst/>
@@ -6224,11 +6224,11 @@
           <a:p>
             <a:pPr>
               <a:spcAft>
-                <a:spcPts val="700"/>
-              </a:spcAft>
-            </a:pPr>
-            <a:r>
-              <a:rPr sz="1900" b="0" i="0">
+                <a:spcPts val="800"/>
+              </a:spcAft>
+            </a:pPr>
+            <a:r>
+              <a:rPr sz="2300" b="0" i="0">
                 <a:solidFill>
                   <a:srgbClr val="2B2B2B"/>
                 </a:solidFill>
@@ -6240,11 +6240,11 @@
           <a:p>
             <a:pPr>
               <a:spcAft>
-                <a:spcPts val="700"/>
-              </a:spcAft>
-            </a:pPr>
-            <a:r>
-              <a:rPr sz="1900" b="0" i="0">
+                <a:spcPts val="800"/>
+              </a:spcAft>
+            </a:pPr>
+            <a:r>
+              <a:rPr sz="2300" b="0" i="0">
                 <a:solidFill>
                   <a:srgbClr val="2B2B2B"/>
                 </a:solidFill>
@@ -6256,11 +6256,11 @@
           <a:p>
             <a:pPr>
               <a:spcAft>
-                <a:spcPts val="700"/>
-              </a:spcAft>
-            </a:pPr>
-            <a:r>
-              <a:rPr sz="1900" b="0" i="0">
+                <a:spcPts val="800"/>
+              </a:spcAft>
+            </a:pPr>
+            <a:r>
+              <a:rPr sz="2300" b="0" i="0">
                 <a:solidFill>
                   <a:srgbClr val="2B2B2B"/>
                 </a:solidFill>
@@ -6272,11 +6272,11 @@
           <a:p>
             <a:pPr>
               <a:spcAft>
-                <a:spcPts val="700"/>
-              </a:spcAft>
-            </a:pPr>
-            <a:r>
-              <a:rPr sz="1900" b="0" i="0">
+                <a:spcPts val="800"/>
+              </a:spcAft>
+            </a:pPr>
+            <a:r>
+              <a:rPr sz="2300" b="0" i="0">
                 <a:solidFill>
                   <a:srgbClr val="2B2B2B"/>
                 </a:solidFill>
@@ -6288,11 +6288,11 @@
           <a:p>
             <a:pPr>
               <a:spcAft>
-                <a:spcPts val="700"/>
-              </a:spcAft>
-            </a:pPr>
-            <a:r>
-              <a:rPr sz="1900" b="0" i="0">
+                <a:spcPts val="800"/>
+              </a:spcAft>
+            </a:pPr>
+            <a:r>
+              <a:rPr sz="2300" b="0" i="0">
                 <a:solidFill>
                   <a:srgbClr val="2B2B2B"/>
                 </a:solidFill>
@@ -6304,11 +6304,11 @@
           <a:p>
             <a:pPr>
               <a:spcAft>
-                <a:spcPts val="700"/>
-              </a:spcAft>
-            </a:pPr>
-            <a:r>
-              <a:rPr sz="1900" b="0" i="0">
+                <a:spcPts val="800"/>
+              </a:spcAft>
+            </a:pPr>
+            <a:r>
+              <a:rPr sz="2300" b="0" i="0">
                 <a:solidFill>
                   <a:srgbClr val="2B2B2B"/>
                 </a:solidFill>
@@ -6320,11 +6320,11 @@
           <a:p>
             <a:pPr>
               <a:spcAft>
-                <a:spcPts val="700"/>
-              </a:spcAft>
-            </a:pPr>
-            <a:r>
-              <a:rPr sz="1900" b="0" i="0">
+                <a:spcPts val="800"/>
+              </a:spcAft>
+            </a:pPr>
+            <a:r>
+              <a:rPr sz="2300" b="0" i="0">
                 <a:solidFill>
                   <a:srgbClr val="2B2B2B"/>
                 </a:solidFill>
@@ -6366,7 +6366,7 @@
               </a:spcAft>
             </a:pPr>
             <a:r>
-              <a:rPr sz="1100" b="0" i="0">
+              <a:rPr sz="1200" b="0" i="0">
                 <a:solidFill>
                   <a:srgbClr val="1F3A5F"/>
                 </a:solidFill>
@@ -6385,8 +6385,8 @@
         </p:nvSpPr>
         <p:spPr>
           <a:xfrm>
-            <a:off x="11338560" y="6400800"/>
-            <a:ext cx="731520" cy="365760"/>
+            <a:off x="11247120" y="6400800"/>
+            <a:ext cx="822960" cy="365760"/>
           </a:xfrm>
           <a:prstGeom prst="rect">
             <a:avLst/>
@@ -6408,7 +6408,7 @@
               </a:spcAft>
             </a:pPr>
             <a:r>
-              <a:rPr sz="1100" b="0" i="0">
+              <a:rPr sz="1200" b="0" i="0">
                 <a:solidFill>
                   <a:srgbClr val="1F3A5F"/>
                 </a:solidFill>
@@ -6533,8 +6533,8 @@
         </p:nvSpPr>
         <p:spPr>
           <a:xfrm>
-            <a:off x="0" y="2788920"/>
-            <a:ext cx="12191695" cy="54864"/>
+            <a:off x="0" y="2743200"/>
+            <a:ext cx="12191695" cy="64008"/>
           </a:xfrm>
           <a:prstGeom prst="rect">
             <a:avLst/>
@@ -6577,7 +6577,7 @@
         </p:nvSpPr>
         <p:spPr>
           <a:xfrm>
-            <a:off x="914400" y="1828800"/>
+            <a:off x="914400" y="1737360"/>
             <a:ext cx="10332720" cy="914400"/>
           </a:xfrm>
           <a:prstGeom prst="rect">
@@ -6600,7 +6600,7 @@
               </a:spcAft>
             </a:pPr>
             <a:r>
-              <a:rPr sz="2200" b="1" i="0">
+              <a:rPr sz="2800" b="1" i="0">
                 <a:solidFill>
                   <a:srgbClr val="C9A227"/>
                 </a:solidFill>
@@ -6619,8 +6619,8 @@
         </p:nvSpPr>
         <p:spPr>
           <a:xfrm>
-            <a:off x="914400" y="2926080"/>
-            <a:ext cx="10332720" cy="1828800"/>
+            <a:off x="640080" y="2880360"/>
+            <a:ext cx="10881360" cy="1828800"/>
           </a:xfrm>
           <a:prstGeom prst="rect">
             <a:avLst/>
@@ -6642,7 +6642,7 @@
               </a:spcAft>
             </a:pPr>
             <a:r>
-              <a:rPr sz="4000" b="1" i="0">
+              <a:rPr sz="5000" b="1" i="0">
                 <a:solidFill>
                   <a:srgbClr val="FFFFFF"/>
                 </a:solidFill>
@@ -6661,7 +6661,7 @@
         </p:nvSpPr>
         <p:spPr>
           <a:xfrm>
-            <a:off x="914400" y="4572000"/>
+            <a:off x="914400" y="4663440"/>
             <a:ext cx="10332720" cy="731520"/>
           </a:xfrm>
           <a:prstGeom prst="rect">
@@ -6684,7 +6684,7 @@
               </a:spcAft>
             </a:pPr>
             <a:r>
-              <a:rPr sz="2000" b="0" i="1">
+              <a:rPr sz="2400" b="0" i="1">
                 <a:solidFill>
                   <a:srgbClr val="F6F2E8"/>
                 </a:solidFill>
@@ -6766,7 +6766,7 @@
         <p:spPr>
           <a:xfrm>
             <a:off x="0" y="0"/>
-            <a:ext cx="12191695" cy="1143000"/>
+            <a:ext cx="12191695" cy="1188720"/>
           </a:xfrm>
           <a:prstGeom prst="rect">
             <a:avLst/>
@@ -6809,8 +6809,8 @@
         </p:nvSpPr>
         <p:spPr>
           <a:xfrm>
-            <a:off x="0" y="1143000"/>
-            <a:ext cx="12191695" cy="73152"/>
+            <a:off x="0" y="1188720"/>
+            <a:ext cx="12191695" cy="82296"/>
           </a:xfrm>
           <a:prstGeom prst="rect">
             <a:avLst/>
@@ -6853,7 +6853,7 @@
         </p:nvSpPr>
         <p:spPr>
           <a:xfrm>
-            <a:off x="548640" y="256032"/>
+            <a:off x="548640" y="201168"/>
             <a:ext cx="11064240" cy="868680"/>
           </a:xfrm>
           <a:prstGeom prst="rect">
@@ -6876,7 +6876,7 @@
               </a:spcAft>
             </a:pPr>
             <a:r>
-              <a:rPr sz="3000" b="1" i="0">
+              <a:rPr sz="3400" b="1" i="0">
                 <a:solidFill>
                   <a:srgbClr val="FFFFFF"/>
                 </a:solidFill>
@@ -6895,8 +6895,8 @@
         </p:nvSpPr>
         <p:spPr>
           <a:xfrm>
-            <a:off x="548640" y="841248"/>
-            <a:ext cx="11064240" cy="320040"/>
+            <a:off x="566928" y="868680"/>
+            <a:ext cx="11064240" cy="365760"/>
           </a:xfrm>
           <a:prstGeom prst="rect">
             <a:avLst/>
@@ -6918,13 +6918,13 @@
               </a:spcAft>
             </a:pPr>
             <a:r>
-              <a:rPr sz="1500" b="1" i="1">
+              <a:rPr sz="1800" b="1" i="1">
                 <a:solidFill>
                   <a:srgbClr val="C9A227"/>
                 </a:solidFill>
                 <a:latin typeface="Calibri"/>
               </a:rPr>
-              <a:t>Romanos 12.9</a:t>
+              <a:t>Romanos 12.9-10</a:t>
             </a:r>
           </a:p>
         </p:txBody>
@@ -6937,8 +6937,8 @@
         </p:nvSpPr>
         <p:spPr>
           <a:xfrm>
-            <a:off x="822960" y="1645920"/>
-            <a:ext cx="10515600" cy="1371600"/>
+            <a:off x="822960" y="1600200"/>
+            <a:ext cx="10515600" cy="1463040"/>
           </a:xfrm>
           <a:prstGeom prst="roundRect">
             <a:avLst/>
@@ -6968,7 +6968,7 @@
           </a:fontRef>
         </p:style>
         <p:txBody>
-          <a:bodyPr rtlCol="0" anchor="ctr" wrap="square" lIns="365760" rIns="320040"/>
+          <a:bodyPr rtlCol="0" anchor="ctr" wrap="square" lIns="411480" rIns="365760"/>
           <a:lstStyle/>
           <a:p>
             <a:pPr algn="l">
@@ -6980,7 +6980,7 @@
               </a:spcAft>
             </a:pPr>
             <a:r>
-              <a:rPr sz="1900" b="0" i="1">
+              <a:rPr sz="2500" b="0" i="1">
                 <a:solidFill>
                   <a:srgbClr val="162A45"/>
                 </a:solidFill>
@@ -6999,7 +6999,7 @@
               </a:spcAft>
             </a:pPr>
             <a:r>
-              <a:rPr sz="1500" b="1" i="0">
+              <a:rPr sz="1900" b="1" i="0">
                 <a:solidFill>
                   <a:srgbClr val="2E6E6A"/>
                 </a:solidFill>
@@ -7018,8 +7018,8 @@
         </p:nvSpPr>
         <p:spPr>
           <a:xfrm>
-            <a:off x="822960" y="1645920"/>
-            <a:ext cx="118872" cy="1371600"/>
+            <a:off x="822960" y="1600200"/>
+            <a:ext cx="137160" cy="1463040"/>
           </a:xfrm>
           <a:prstGeom prst="rect">
             <a:avLst/>
@@ -7063,7 +7063,7 @@
         <p:spPr>
           <a:xfrm>
             <a:off x="822960" y="3383280"/>
-            <a:ext cx="10515600" cy="2743200"/>
+            <a:ext cx="10607040" cy="2834640"/>
           </a:xfrm>
           <a:prstGeom prst="rect">
             <a:avLst/>
@@ -7078,49 +7078,49 @@
           <a:p>
             <a:pPr>
               <a:spcAft>
-                <a:spcPts val="1200"/>
-              </a:spcAft>
-            </a:pPr>
-            <a:r>
-              <a:rPr sz="2000" b="1" i="0">
+                <a:spcPts val="1400"/>
+              </a:spcAft>
+            </a:pPr>
+            <a:r>
+              <a:rPr sz="2600" b="1" i="0">
                 <a:solidFill>
                   <a:srgbClr val="1F3A5F"/>
                 </a:solidFill>
                 <a:latin typeface="Calibri"/>
               </a:rPr>
-              <a:t>• O amor (gr. ágape) é o sistema circulatório do corpo espiritual: faz todos os membros funcionarem de forma saudável.</a:t>
+              <a:t>• O amor (ágape) é o sistema circulatório do corpo espiritual: faz todos os membros funcionarem de forma saudável.</a:t>
             </a:r>
           </a:p>
           <a:p>
             <a:pPr>
               <a:spcAft>
-                <a:spcPts val="1000"/>
-              </a:spcAft>
-            </a:pPr>
-            <a:r>
-              <a:rPr sz="2000" b="0" i="0">
+                <a:spcPts val="1400"/>
+              </a:spcAft>
+            </a:pPr>
+            <a:r>
+              <a:rPr sz="2500" b="0" i="0">
                 <a:solidFill>
                   <a:srgbClr val="2B2B2B"/>
                 </a:solidFill>
                 <a:latin typeface="Calibri"/>
               </a:rPr>
-              <a:t>• Amor sincero (sem máscara), com discernimento: detestar o mal, apegar-se ao bem.</a:t>
+              <a:t>• Amor sincero, sem máscara, com discernimento: detestar o mal, apegar-se ao bem.</a:t>
             </a:r>
           </a:p>
           <a:p>
             <a:pPr>
               <a:spcAft>
-                <a:spcPts val="1000"/>
-              </a:spcAft>
-            </a:pPr>
-            <a:r>
-              <a:rPr sz="2000" b="0" i="0">
+                <a:spcPts val="1400"/>
+              </a:spcAft>
+            </a:pPr>
+            <a:r>
+              <a:rPr sz="2500" b="0" i="0">
                 <a:solidFill>
                   <a:srgbClr val="2B2B2B"/>
                 </a:solidFill>
                 <a:latin typeface="Calibri"/>
               </a:rPr>
-              <a:t>• Afeição fraternal e honra mútua: “preferíndo-vos em honra uns aos outros” (12.10).</a:t>
+              <a:t>• Afeição fraternal e honra mútua: “preferindo-vos em honra uns aos outros” (12.10).</a:t>
             </a:r>
           </a:p>
         </p:txBody>
@@ -7156,7 +7156,7 @@
               </a:spcAft>
             </a:pPr>
             <a:r>
-              <a:rPr sz="1100" b="0" i="0">
+              <a:rPr sz="1200" b="0" i="0">
                 <a:solidFill>
                   <a:srgbClr val="1F3A5F"/>
                 </a:solidFill>
@@ -7175,8 +7175,8 @@
         </p:nvSpPr>
         <p:spPr>
           <a:xfrm>
-            <a:off x="11338560" y="6400800"/>
-            <a:ext cx="731520" cy="365760"/>
+            <a:off x="11247120" y="6400800"/>
+            <a:ext cx="822960" cy="365760"/>
           </a:xfrm>
           <a:prstGeom prst="rect">
             <a:avLst/>
@@ -7198,7 +7198,7 @@
               </a:spcAft>
             </a:pPr>
             <a:r>
-              <a:rPr sz="1100" b="0" i="0">
+              <a:rPr sz="1200" b="0" i="0">
                 <a:solidFill>
                   <a:srgbClr val="1F3A5F"/>
                 </a:solidFill>
@@ -7280,7 +7280,7 @@
         <p:spPr>
           <a:xfrm>
             <a:off x="0" y="0"/>
-            <a:ext cx="12191695" cy="1143000"/>
+            <a:ext cx="12191695" cy="1188720"/>
           </a:xfrm>
           <a:prstGeom prst="rect">
             <a:avLst/>
@@ -7323,8 +7323,8 @@
         </p:nvSpPr>
         <p:spPr>
           <a:xfrm>
-            <a:off x="0" y="1143000"/>
-            <a:ext cx="12191695" cy="73152"/>
+            <a:off x="0" y="1188720"/>
+            <a:ext cx="12191695" cy="82296"/>
           </a:xfrm>
           <a:prstGeom prst="rect">
             <a:avLst/>
@@ -7367,7 +7367,7 @@
         </p:nvSpPr>
         <p:spPr>
           <a:xfrm>
-            <a:off x="548640" y="256032"/>
+            <a:off x="548640" y="201168"/>
             <a:ext cx="11064240" cy="868680"/>
           </a:xfrm>
           <a:prstGeom prst="rect">
@@ -7390,7 +7390,7 @@
               </a:spcAft>
             </a:pPr>
             <a:r>
-              <a:rPr sz="3000" b="1" i="0">
+              <a:rPr sz="3400" b="1" i="0">
                 <a:solidFill>
                   <a:srgbClr val="FFFFFF"/>
                 </a:solidFill>
@@ -7409,8 +7409,8 @@
         </p:nvSpPr>
         <p:spPr>
           <a:xfrm>
-            <a:off x="548640" y="841248"/>
-            <a:ext cx="11064240" cy="320040"/>
+            <a:off x="566928" y="868680"/>
+            <a:ext cx="11064240" cy="365760"/>
           </a:xfrm>
           <a:prstGeom prst="rect">
             <a:avLst/>
@@ -7432,7 +7432,7 @@
               </a:spcAft>
             </a:pPr>
             <a:r>
-              <a:rPr sz="1500" b="1" i="1">
+              <a:rPr sz="1800" b="1" i="1">
                 <a:solidFill>
                   <a:srgbClr val="C9A227"/>
                 </a:solidFill>
@@ -7451,8 +7451,8 @@
         </p:nvSpPr>
         <p:spPr>
           <a:xfrm>
-            <a:off x="822960" y="1645920"/>
-            <a:ext cx="10515600" cy="960120"/>
+            <a:off x="822960" y="1600200"/>
+            <a:ext cx="10515600" cy="1024128"/>
           </a:xfrm>
           <a:prstGeom prst="roundRect">
             <a:avLst/>
@@ -7482,12 +7482,12 @@
           </a:fontRef>
         </p:style>
         <p:txBody>
-          <a:bodyPr rtlCol="0" anchor="ctr" wrap="square" lIns="320040"/>
+          <a:bodyPr rtlCol="0" anchor="ctr" wrap="square" lIns="365760"/>
           <a:lstStyle/>
           <a:p>
             <a:pPr algn="ctr"/>
             <a:r>
-              <a:rPr b="1" sz="2000">
+              <a:rPr b="1" sz="2400">
                 <a:solidFill>
                   <a:srgbClr val="1F3A5F"/>
                 </a:solidFill>
@@ -7496,13 +7496,13 @@
               <a:t>Coração aberto  —  </a:t>
             </a:r>
             <a:r>
-              <a:rPr sz="1900">
+              <a:rPr sz="2200">
                 <a:solidFill>
                   <a:srgbClr val="2B2B2B"/>
                 </a:solidFill>
                 <a:latin typeface="Calibri"/>
               </a:rPr>
-              <a:t>Amor fraternal, sincero e cordial (12.9-10)</a:t>
+              <a:t>amor fraternal, sincero e cordial (12.9-10)</a:t>
             </a:r>
           </a:p>
         </p:txBody>
@@ -7515,8 +7515,8 @@
         </p:nvSpPr>
         <p:spPr>
           <a:xfrm>
-            <a:off x="822960" y="2743200"/>
-            <a:ext cx="10515600" cy="960120"/>
+            <a:off x="822960" y="2770632"/>
+            <a:ext cx="10515600" cy="1024128"/>
           </a:xfrm>
           <a:prstGeom prst="roundRect">
             <a:avLst/>
@@ -7546,12 +7546,12 @@
           </a:fontRef>
         </p:style>
         <p:txBody>
-          <a:bodyPr rtlCol="0" anchor="ctr" wrap="square" lIns="320040"/>
+          <a:bodyPr rtlCol="0" anchor="ctr" wrap="square" lIns="365760"/>
           <a:lstStyle/>
           <a:p>
             <a:pPr algn="ctr"/>
             <a:r>
-              <a:rPr b="1" sz="2000">
+              <a:rPr b="1" sz="2400">
                 <a:solidFill>
                   <a:srgbClr val="1F3A5F"/>
                 </a:solidFill>
@@ -7560,13 +7560,13 @@
               <a:t>Lábios abertos  —  </a:t>
             </a:r>
             <a:r>
-              <a:rPr sz="1900">
+              <a:rPr sz="2200">
                 <a:solidFill>
                   <a:srgbClr val="2B2B2B"/>
                 </a:solidFill>
                 <a:latin typeface="Calibri"/>
               </a:rPr>
-              <a:t>Abençoar e não amaldiçoar (12.14)</a:t>
+              <a:t>abençoar e não amaldiçoar (12.14)</a:t>
             </a:r>
           </a:p>
         </p:txBody>
@@ -7579,8 +7579,8 @@
         </p:nvSpPr>
         <p:spPr>
           <a:xfrm>
-            <a:off x="822960" y="3840480"/>
-            <a:ext cx="10515600" cy="960120"/>
+            <a:off x="822960" y="3941064"/>
+            <a:ext cx="10515600" cy="1024128"/>
           </a:xfrm>
           <a:prstGeom prst="roundRect">
             <a:avLst/>
@@ -7610,12 +7610,12 @@
           </a:fontRef>
         </p:style>
         <p:txBody>
-          <a:bodyPr rtlCol="0" anchor="ctr" wrap="square" lIns="320040"/>
+          <a:bodyPr rtlCol="0" anchor="ctr" wrap="square" lIns="365760"/>
           <a:lstStyle/>
           <a:p>
             <a:pPr algn="ctr"/>
             <a:r>
-              <a:rPr b="1" sz="2000">
+              <a:rPr b="1" sz="2400">
                 <a:solidFill>
                   <a:srgbClr val="1F3A5F"/>
                 </a:solidFill>
@@ -7624,13 +7624,13 @@
               <a:t>Mãos abertas  —  </a:t>
             </a:r>
             <a:r>
-              <a:rPr sz="1900">
+              <a:rPr sz="2200">
                 <a:solidFill>
                   <a:srgbClr val="2B2B2B"/>
                 </a:solidFill>
                 <a:latin typeface="Calibri"/>
               </a:rPr>
-              <a:t>Repartir com os santos nas necessidades (12.13a)</a:t>
+              <a:t>repartir com os santos nas necessidades (12.13a)</a:t>
             </a:r>
           </a:p>
         </p:txBody>
@@ -7643,8 +7643,8 @@
         </p:nvSpPr>
         <p:spPr>
           <a:xfrm>
-            <a:off x="822960" y="4937760"/>
-            <a:ext cx="10515600" cy="960120"/>
+            <a:off x="822960" y="5111496"/>
+            <a:ext cx="10515600" cy="1024128"/>
           </a:xfrm>
           <a:prstGeom prst="roundRect">
             <a:avLst/>
@@ -7674,12 +7674,12 @@
           </a:fontRef>
         </p:style>
         <p:txBody>
-          <a:bodyPr rtlCol="0" anchor="ctr" wrap="square" lIns="320040"/>
+          <a:bodyPr rtlCol="0" anchor="ctr" wrap="square" lIns="365760"/>
           <a:lstStyle/>
           <a:p>
             <a:pPr algn="ctr"/>
             <a:r>
-              <a:rPr b="1" sz="2000">
+              <a:rPr b="1" sz="2400">
                 <a:solidFill>
                   <a:srgbClr val="1F3A5F"/>
                 </a:solidFill>
@@ -7688,13 +7688,13 @@
               <a:t>Casa aberta  —  </a:t>
             </a:r>
             <a:r>
-              <a:rPr sz="1900">
+              <a:rPr sz="2200">
                 <a:solidFill>
                   <a:srgbClr val="2B2B2B"/>
                 </a:solidFill>
                 <a:latin typeface="Calibri"/>
               </a:rPr>
-              <a:t>Praticar a hospitalidade — acolher (12.13b)</a:t>
+              <a:t>praticar a hospitalidade — acolher (12.13b)</a:t>
             </a:r>
           </a:p>
         </p:txBody>
@@ -7730,7 +7730,7 @@
               </a:spcAft>
             </a:pPr>
             <a:r>
-              <a:rPr sz="1100" b="0" i="0">
+              <a:rPr sz="1200" b="0" i="0">
                 <a:solidFill>
                   <a:srgbClr val="1F3A5F"/>
                 </a:solidFill>
@@ -7749,8 +7749,8 @@
         </p:nvSpPr>
         <p:spPr>
           <a:xfrm>
-            <a:off x="11338560" y="6400800"/>
-            <a:ext cx="731520" cy="365760"/>
+            <a:off x="11247120" y="6400800"/>
+            <a:ext cx="822960" cy="365760"/>
           </a:xfrm>
           <a:prstGeom prst="rect">
             <a:avLst/>
@@ -7772,7 +7772,7 @@
               </a:spcAft>
             </a:pPr>
             <a:r>
-              <a:rPr sz="1100" b="0" i="0">
+              <a:rPr sz="1200" b="0" i="0">
                 <a:solidFill>
                   <a:srgbClr val="1F3A5F"/>
                 </a:solidFill>
@@ -7854,7 +7854,7 @@
         <p:spPr>
           <a:xfrm>
             <a:off x="0" y="0"/>
-            <a:ext cx="12191695" cy="1143000"/>
+            <a:ext cx="12191695" cy="1188720"/>
           </a:xfrm>
           <a:prstGeom prst="rect">
             <a:avLst/>
@@ -7897,8 +7897,8 @@
         </p:nvSpPr>
         <p:spPr>
           <a:xfrm>
-            <a:off x="0" y="1143000"/>
-            <a:ext cx="12191695" cy="73152"/>
+            <a:off x="0" y="1188720"/>
+            <a:ext cx="12191695" cy="82296"/>
           </a:xfrm>
           <a:prstGeom prst="rect">
             <a:avLst/>
@@ -7941,7 +7941,7 @@
         </p:nvSpPr>
         <p:spPr>
           <a:xfrm>
-            <a:off x="548640" y="256032"/>
+            <a:off x="548640" y="201168"/>
             <a:ext cx="11064240" cy="868680"/>
           </a:xfrm>
           <a:prstGeom prst="rect">
@@ -7964,7 +7964,7 @@
               </a:spcAft>
             </a:pPr>
             <a:r>
-              <a:rPr sz="3000" b="1" i="0">
+              <a:rPr sz="3400" b="1" i="0">
                 <a:solidFill>
                   <a:srgbClr val="FFFFFF"/>
                 </a:solidFill>
@@ -7983,8 +7983,8 @@
         </p:nvSpPr>
         <p:spPr>
           <a:xfrm>
-            <a:off x="548640" y="841248"/>
-            <a:ext cx="11064240" cy="320040"/>
+            <a:off x="566928" y="868680"/>
+            <a:ext cx="11064240" cy="365760"/>
           </a:xfrm>
           <a:prstGeom prst="rect">
             <a:avLst/>
@@ -8006,7 +8006,7 @@
               </a:spcAft>
             </a:pPr>
             <a:r>
-              <a:rPr sz="1500" b="1" i="1">
+              <a:rPr sz="1800" b="1" i="1">
                 <a:solidFill>
                   <a:srgbClr val="C9A227"/>
                 </a:solidFill>
@@ -8025,8 +8025,8 @@
         </p:nvSpPr>
         <p:spPr>
           <a:xfrm>
-            <a:off x="822960" y="1508760"/>
-            <a:ext cx="10515600" cy="2194560"/>
+            <a:off x="822960" y="1554480"/>
+            <a:ext cx="10607040" cy="2377440"/>
           </a:xfrm>
           <a:prstGeom prst="rect">
             <a:avLst/>
@@ -8041,33 +8041,33 @@
           <a:p>
             <a:pPr>
               <a:spcAft>
-                <a:spcPts val="1000"/>
-              </a:spcAft>
-            </a:pPr>
-            <a:r>
-              <a:rPr sz="2000" b="0" i="0">
+                <a:spcPts val="1400"/>
+              </a:spcAft>
+            </a:pPr>
+            <a:r>
+              <a:rPr sz="2600" b="0" i="0">
                 <a:solidFill>
                   <a:srgbClr val="2B2B2B"/>
                 </a:solidFill>
                 <a:latin typeface="Calibri"/>
               </a:rPr>
-              <a:t>• A unidade cristã alcança até os inimigos: não retaliar, não criar conflitos, não vingar-se, não guardar mágoa.</a:t>
+              <a:t>• A unidade cristã alcança até os inimigos: não retaliar, não vingar-se, não guardar mágoa.</a:t>
             </a:r>
           </a:p>
           <a:p>
             <a:pPr>
               <a:spcAft>
-                <a:spcPts val="1000"/>
-              </a:spcAft>
-            </a:pPr>
-            <a:r>
-              <a:rPr sz="2000" b="0" i="0">
+                <a:spcPts val="1400"/>
+              </a:spcAft>
+            </a:pPr>
+            <a:r>
+              <a:rPr sz="2600" b="0" i="0">
                 <a:solidFill>
                   <a:srgbClr val="2B2B2B"/>
                 </a:solidFill>
                 <a:latin typeface="Calibri"/>
               </a:rPr>
-              <a:t>• “Se possível, quanto depender de vós, tende paz com todos os homens” (12.18). O cristão é pacificador, apaga focos de incêndio.</a:t>
+              <a:t>• “Se possível, quanto depender de vós, tende paz com todos os homens” (12.18). O cristão é pacificador.</a:t>
             </a:r>
           </a:p>
         </p:txBody>
@@ -8080,8 +8080,8 @@
         </p:nvSpPr>
         <p:spPr>
           <a:xfrm>
-            <a:off x="822960" y="4023360"/>
-            <a:ext cx="10515600" cy="1280160"/>
+            <a:off x="822960" y="4572000"/>
+            <a:ext cx="10515600" cy="1371600"/>
           </a:xfrm>
           <a:prstGeom prst="roundRect">
             <a:avLst/>
@@ -8111,7 +8111,7 @@
           </a:fontRef>
         </p:style>
         <p:txBody>
-          <a:bodyPr rtlCol="0" anchor="ctr" wrap="square" lIns="365760" rIns="320040"/>
+          <a:bodyPr rtlCol="0" anchor="ctr" wrap="square" lIns="411480" rIns="365760"/>
           <a:lstStyle/>
           <a:p>
             <a:pPr algn="l">
@@ -8123,7 +8123,7 @@
               </a:spcAft>
             </a:pPr>
             <a:r>
-              <a:rPr sz="1900" b="0" i="1">
+              <a:rPr sz="2500" b="0" i="1">
                 <a:solidFill>
                   <a:srgbClr val="162A45"/>
                 </a:solidFill>
@@ -8142,7 +8142,7 @@
               </a:spcAft>
             </a:pPr>
             <a:r>
-              <a:rPr sz="1500" b="1" i="0">
+              <a:rPr sz="1900" b="1" i="0">
                 <a:solidFill>
                   <a:srgbClr val="2E6E6A"/>
                 </a:solidFill>
@@ -8161,8 +8161,8 @@
         </p:nvSpPr>
         <p:spPr>
           <a:xfrm>
-            <a:off x="822960" y="4023360"/>
-            <a:ext cx="118872" cy="1280160"/>
+            <a:off x="822960" y="4572000"/>
+            <a:ext cx="137160" cy="1371600"/>
           </a:xfrm>
           <a:prstGeom prst="rect">
             <a:avLst/>
@@ -8228,7 +8228,7 @@
               </a:spcAft>
             </a:pPr>
             <a:r>
-              <a:rPr sz="1100" b="0" i="0">
+              <a:rPr sz="1200" b="0" i="0">
                 <a:solidFill>
                   <a:srgbClr val="1F3A5F"/>
                 </a:solidFill>
@@ -8247,8 +8247,8 @@
         </p:nvSpPr>
         <p:spPr>
           <a:xfrm>
-            <a:off x="11338560" y="6400800"/>
-            <a:ext cx="731520" cy="365760"/>
+            <a:off x="11247120" y="6400800"/>
+            <a:ext cx="822960" cy="365760"/>
           </a:xfrm>
           <a:prstGeom prst="rect">
             <a:avLst/>
@@ -8270,7 +8270,7 @@
               </a:spcAft>
             </a:pPr>
             <a:r>
-              <a:rPr sz="1100" b="0" i="0">
+              <a:rPr sz="1200" b="0" i="0">
                 <a:solidFill>
                   <a:srgbClr val="1F3A5F"/>
                 </a:solidFill>
@@ -8418,7 +8418,7 @@
               </a:spcAft>
             </a:pPr>
             <a:r>
-              <a:rPr sz="1800" b="1" i="0">
+              <a:rPr sz="2200" b="1" i="0">
                 <a:solidFill>
                   <a:srgbClr val="C9A227"/>
                 </a:solidFill>
@@ -8437,8 +8437,8 @@
         </p:nvSpPr>
         <p:spPr>
           <a:xfrm>
-            <a:off x="1097280" y="1920240"/>
-            <a:ext cx="9966960" cy="2743200"/>
+            <a:off x="914400" y="1828800"/>
+            <a:ext cx="10332720" cy="2926080"/>
           </a:xfrm>
           <a:prstGeom prst="rect">
             <a:avLst/>
@@ -8460,7 +8460,7 @@
               </a:spcAft>
             </a:pPr>
             <a:r>
-              <a:rPr sz="3400" b="0" i="1">
+              <a:rPr sz="4000" b="0" i="1">
                 <a:solidFill>
                   <a:srgbClr val="FFFFFF"/>
                 </a:solidFill>
@@ -8479,7 +8479,7 @@
         </p:nvSpPr>
         <p:spPr>
           <a:xfrm>
-            <a:off x="1097280" y="4754880"/>
+            <a:off x="1097280" y="5029200"/>
             <a:ext cx="9966960" cy="640080"/>
           </a:xfrm>
           <a:prstGeom prst="rect">
@@ -8502,7 +8502,7 @@
               </a:spcAft>
             </a:pPr>
             <a:r>
-              <a:rPr sz="2400" b="1" i="0">
+              <a:rPr sz="2800" b="1" i="0">
                 <a:solidFill>
                   <a:srgbClr val="C9A227"/>
                 </a:solidFill>
@@ -8627,8 +8627,8 @@
         </p:nvSpPr>
         <p:spPr>
           <a:xfrm>
-            <a:off x="0" y="1143000"/>
-            <a:ext cx="12191695" cy="73152"/>
+            <a:off x="0" y="1188720"/>
+            <a:ext cx="12191695" cy="82296"/>
           </a:xfrm>
           <a:prstGeom prst="rect">
             <a:avLst/>
@@ -8671,8 +8671,8 @@
         </p:nvSpPr>
         <p:spPr>
           <a:xfrm>
-            <a:off x="548640" y="365760"/>
-            <a:ext cx="10972800" cy="822960"/>
+            <a:off x="548640" y="292608"/>
+            <a:ext cx="10972800" cy="868680"/>
           </a:xfrm>
           <a:prstGeom prst="rect">
             <a:avLst/>
@@ -8694,7 +8694,7 @@
               </a:spcAft>
             </a:pPr>
             <a:r>
-              <a:rPr sz="3200" b="1" i="0">
+              <a:rPr sz="3400" b="1" i="0">
                 <a:solidFill>
                   <a:srgbClr val="FFFFFF"/>
                 </a:solidFill>
@@ -8714,7 +8714,7 @@
         <p:spPr>
           <a:xfrm>
             <a:off x="822960" y="1554480"/>
-            <a:ext cx="10515600" cy="4572000"/>
+            <a:ext cx="10607040" cy="4663440"/>
           </a:xfrm>
           <a:prstGeom prst="rect">
             <a:avLst/>
@@ -8733,7 +8733,7 @@
               </a:spcAft>
             </a:pPr>
             <a:r>
-              <a:rPr sz="2100" b="0" i="0">
+              <a:rPr sz="2500" b="0" i="0">
                 <a:solidFill>
                   <a:srgbClr val="F6F2E8"/>
                 </a:solidFill>
@@ -8749,7 +8749,7 @@
               </a:spcAft>
             </a:pPr>
             <a:r>
-              <a:rPr sz="2100" b="0" i="0">
+              <a:rPr sz="2500" b="0" i="0">
                 <a:solidFill>
                   <a:srgbClr val="F6F2E8"/>
                 </a:solidFill>
@@ -8765,7 +8765,7 @@
               </a:spcAft>
             </a:pPr>
             <a:r>
-              <a:rPr sz="2100" b="0" i="0">
+              <a:rPr sz="2500" b="0" i="0">
                 <a:solidFill>
                   <a:srgbClr val="F6F2E8"/>
                 </a:solidFill>
@@ -8781,7 +8781,7 @@
               </a:spcAft>
             </a:pPr>
             <a:r>
-              <a:rPr sz="2100" b="0" i="0">
+              <a:rPr sz="2500" b="0" i="0">
                 <a:solidFill>
                   <a:srgbClr val="F6F2E8"/>
                 </a:solidFill>
@@ -8793,11 +8793,11 @@
           <a:p>
             <a:pPr>
               <a:spcAft>
-                <a:spcPts val="1000"/>
-              </a:spcAft>
-            </a:pPr>
-            <a:r>
-              <a:rPr sz="2100" b="1" i="0">
+                <a:spcPts val="1400"/>
+              </a:spcAft>
+            </a:pPr>
+            <a:r>
+              <a:rPr sz="2500" b="1" i="0">
                 <a:solidFill>
                   <a:srgbClr val="C9A227"/>
                 </a:solidFill>
@@ -8879,7 +8879,7 @@
         <p:spPr>
           <a:xfrm>
             <a:off x="0" y="0"/>
-            <a:ext cx="12191695" cy="1143000"/>
+            <a:ext cx="12191695" cy="1188720"/>
           </a:xfrm>
           <a:prstGeom prst="rect">
             <a:avLst/>
@@ -8922,8 +8922,8 @@
         </p:nvSpPr>
         <p:spPr>
           <a:xfrm>
-            <a:off x="0" y="1143000"/>
-            <a:ext cx="12191695" cy="73152"/>
+            <a:off x="0" y="1188720"/>
+            <a:ext cx="12191695" cy="82296"/>
           </a:xfrm>
           <a:prstGeom prst="rect">
             <a:avLst/>
@@ -8966,7 +8966,7 @@
         </p:nvSpPr>
         <p:spPr>
           <a:xfrm>
-            <a:off x="548640" y="256032"/>
+            <a:off x="548640" y="201168"/>
             <a:ext cx="11064240" cy="868680"/>
           </a:xfrm>
           <a:prstGeom prst="rect">
@@ -8989,7 +8989,7 @@
               </a:spcAft>
             </a:pPr>
             <a:r>
-              <a:rPr sz="3000" b="1" i="0">
+              <a:rPr sz="3400" b="1" i="0">
                 <a:solidFill>
                   <a:srgbClr val="FFFFFF"/>
                 </a:solidFill>
@@ -9008,8 +9008,8 @@
         </p:nvSpPr>
         <p:spPr>
           <a:xfrm>
-            <a:off x="822960" y="1645920"/>
-            <a:ext cx="10515600" cy="2743200"/>
+            <a:off x="822960" y="1600200"/>
+            <a:ext cx="10607040" cy="2926080"/>
           </a:xfrm>
           <a:prstGeom prst="rect">
             <a:avLst/>
@@ -9024,11 +9024,11 @@
           <a:p>
             <a:pPr>
               <a:spcAft>
-                <a:spcPts val="1600"/>
-              </a:spcAft>
-            </a:pPr>
-            <a:r>
-              <a:rPr sz="2200" b="1" i="0">
+                <a:spcPts val="1400"/>
+              </a:spcAft>
+            </a:pPr>
+            <a:r>
+              <a:rPr sz="2800" b="1" i="0">
                 <a:solidFill>
                   <a:srgbClr val="1F3A5F"/>
                 </a:solidFill>
@@ -9044,29 +9044,29 @@
               </a:spcAft>
             </a:pPr>
             <a:r>
-              <a:rPr sz="2100" b="0" i="0">
+              <a:rPr sz="2600" b="0" i="0">
                 <a:solidFill>
                   <a:srgbClr val="2B2B2B"/>
                 </a:solidFill>
                 <a:latin typeface="Calibri"/>
               </a:rPr>
-              <a:t>• A unidade é dom de Deus — recebida pela graça. A diversidade é presente de Deus para nos enriquecer. O amor é o que mantém tudo unido.</a:t>
+              <a:t>• A unidade é dom recebido pela graça; a diversidade nos enriquece; o amor mantém tudo unido.</a:t>
             </a:r>
           </a:p>
           <a:p>
             <a:pPr>
               <a:spcAft>
-                <a:spcPts val="1000"/>
-              </a:spcAft>
-            </a:pPr>
-            <a:r>
-              <a:rPr sz="2100" b="0" i="0">
+                <a:spcPts val="1400"/>
+              </a:spcAft>
+            </a:pPr>
+            <a:r>
+              <a:rPr sz="2600" b="0" i="0">
                 <a:solidFill>
                   <a:srgbClr val="2B2B2B"/>
                 </a:solidFill>
                 <a:latin typeface="Calibri"/>
               </a:rPr>
-              <a:t>• Sermos um em Cristo não é um ideal distânte: é uma realidade a ser vivida, todos os dias, uns com os outros.</a:t>
+              <a:t>• Ser um em Cristo não é um ideal distante: é uma realidade a ser vivida, todos os dias, uns com os outros.</a:t>
             </a:r>
           </a:p>
         </p:txBody>
@@ -9079,8 +9079,8 @@
         </p:nvSpPr>
         <p:spPr>
           <a:xfrm>
-            <a:off x="822960" y="4937760"/>
-            <a:ext cx="10515600" cy="1005840"/>
+            <a:off x="822960" y="5120640"/>
+            <a:ext cx="10515600" cy="1097280"/>
           </a:xfrm>
           <a:prstGeom prst="roundRect">
             <a:avLst/>
@@ -9110,7 +9110,7 @@
           </a:fontRef>
         </p:style>
         <p:txBody>
-          <a:bodyPr rtlCol="0" anchor="ctr" wrap="square" lIns="365760" rIns="320040"/>
+          <a:bodyPr rtlCol="0" anchor="ctr" wrap="square" lIns="411480" rIns="365760"/>
           <a:lstStyle/>
           <a:p>
             <a:pPr algn="l">
@@ -9122,7 +9122,7 @@
               </a:spcAft>
             </a:pPr>
             <a:r>
-              <a:rPr sz="1900" b="0" i="1">
+              <a:rPr sz="2500" b="0" i="1">
                 <a:solidFill>
                   <a:srgbClr val="162A45"/>
                 </a:solidFill>
@@ -9141,7 +9141,7 @@
               </a:spcAft>
             </a:pPr>
             <a:r>
-              <a:rPr sz="1500" b="1" i="0">
+              <a:rPr sz="1900" b="1" i="0">
                 <a:solidFill>
                   <a:srgbClr val="2E6E6A"/>
                 </a:solidFill>
@@ -9160,8 +9160,8 @@
         </p:nvSpPr>
         <p:spPr>
           <a:xfrm>
-            <a:off x="822960" y="4937760"/>
-            <a:ext cx="118872" cy="1005840"/>
+            <a:off x="822960" y="5120640"/>
+            <a:ext cx="137160" cy="1097280"/>
           </a:xfrm>
           <a:prstGeom prst="rect">
             <a:avLst/>
@@ -9227,7 +9227,7 @@
               </a:spcAft>
             </a:pPr>
             <a:r>
-              <a:rPr sz="1100" b="0" i="0">
+              <a:rPr sz="1200" b="0" i="0">
                 <a:solidFill>
                   <a:srgbClr val="1F3A5F"/>
                 </a:solidFill>
@@ -9246,8 +9246,8 @@
         </p:nvSpPr>
         <p:spPr>
           <a:xfrm>
-            <a:off x="11338560" y="6400800"/>
-            <a:ext cx="731520" cy="365760"/>
+            <a:off x="11247120" y="6400800"/>
+            <a:ext cx="822960" cy="365760"/>
           </a:xfrm>
           <a:prstGeom prst="rect">
             <a:avLst/>
@@ -9269,7 +9269,7 @@
               </a:spcAft>
             </a:pPr>
             <a:r>
-              <a:rPr sz="1100" b="0" i="0">
+              <a:rPr sz="1200" b="0" i="0">
                 <a:solidFill>
                   <a:srgbClr val="1F3A5F"/>
                 </a:solidFill>
@@ -9394,8 +9394,8 @@
         </p:nvSpPr>
         <p:spPr>
           <a:xfrm>
-            <a:off x="0" y="2606040"/>
-            <a:ext cx="12191695" cy="54864"/>
+            <a:off x="0" y="2560320"/>
+            <a:ext cx="12191695" cy="64008"/>
           </a:xfrm>
           <a:prstGeom prst="rect">
             <a:avLst/>
@@ -9438,8 +9438,8 @@
         </p:nvSpPr>
         <p:spPr>
           <a:xfrm>
-            <a:off x="731520" y="2377440"/>
-            <a:ext cx="10698480" cy="1280160"/>
+            <a:off x="548640" y="2286000"/>
+            <a:ext cx="11064240" cy="1280160"/>
           </a:xfrm>
           <a:prstGeom prst="rect">
             <a:avLst/>
@@ -9461,7 +9461,7 @@
               </a:spcAft>
             </a:pPr>
             <a:r>
-              <a:rPr sz="4600" b="1" i="0">
+              <a:rPr sz="5200" b="1" i="0">
                 <a:solidFill>
                   <a:srgbClr val="FFFFFF"/>
                 </a:solidFill>
@@ -9481,7 +9481,7 @@
         <p:spPr>
           <a:xfrm>
             <a:off x="731520" y="3840480"/>
-            <a:ext cx="10698480" cy="731520"/>
+            <a:ext cx="10698480" cy="822960"/>
           </a:xfrm>
           <a:prstGeom prst="rect">
             <a:avLst/>
@@ -9503,7 +9503,7 @@
               </a:spcAft>
             </a:pPr>
             <a:r>
-              <a:rPr sz="2000" b="0" i="1">
+              <a:rPr sz="2400" b="0" i="1">
                 <a:solidFill>
                   <a:srgbClr val="C9A227"/>
                 </a:solidFill>
@@ -9522,7 +9522,7 @@
         </p:nvSpPr>
         <p:spPr>
           <a:xfrm>
-            <a:off x="731520" y="5120640"/>
+            <a:off x="731520" y="5212080"/>
             <a:ext cx="10698480" cy="548640"/>
           </a:xfrm>
           <a:prstGeom prst="rect">
@@ -9545,7 +9545,7 @@
               </a:spcAft>
             </a:pPr>
             <a:r>
-              <a:rPr sz="1500" b="0" i="0">
+              <a:rPr sz="1600" b="0" i="0">
                 <a:solidFill>
                   <a:srgbClr val="F6F2E8"/>
                 </a:solidFill>
@@ -9627,7 +9627,7 @@
         <p:spPr>
           <a:xfrm>
             <a:off x="0" y="0"/>
-            <a:ext cx="12191695" cy="1143000"/>
+            <a:ext cx="12191695" cy="1188720"/>
           </a:xfrm>
           <a:prstGeom prst="rect">
             <a:avLst/>
@@ -9670,8 +9670,8 @@
         </p:nvSpPr>
         <p:spPr>
           <a:xfrm>
-            <a:off x="0" y="1143000"/>
-            <a:ext cx="12191695" cy="73152"/>
+            <a:off x="0" y="1188720"/>
+            <a:ext cx="12191695" cy="82296"/>
           </a:xfrm>
           <a:prstGeom prst="rect">
             <a:avLst/>
@@ -9714,7 +9714,7 @@
         </p:nvSpPr>
         <p:spPr>
           <a:xfrm>
-            <a:off x="548640" y="256032"/>
+            <a:off x="548640" y="201168"/>
             <a:ext cx="11064240" cy="868680"/>
           </a:xfrm>
           <a:prstGeom prst="rect">
@@ -9737,7 +9737,7 @@
               </a:spcAft>
             </a:pPr>
             <a:r>
-              <a:rPr sz="3000" b="1" i="0">
+              <a:rPr sz="3400" b="1" i="0">
                 <a:solidFill>
                   <a:srgbClr val="FFFFFF"/>
                 </a:solidFill>
@@ -9756,8 +9756,8 @@
         </p:nvSpPr>
         <p:spPr>
           <a:xfrm>
-            <a:off x="822960" y="1554480"/>
-            <a:ext cx="10515600" cy="4572000"/>
+            <a:off x="822960" y="1600200"/>
+            <a:ext cx="10607040" cy="4572000"/>
           </a:xfrm>
           <a:prstGeom prst="rect">
             <a:avLst/>
@@ -9776,71 +9776,71 @@
               </a:spcAft>
             </a:pPr>
             <a:r>
-              <a:rPr sz="2100" b="1" i="0">
+              <a:rPr sz="2700" b="1" i="0">
                 <a:solidFill>
                   <a:srgbClr val="1F3A5F"/>
                 </a:solidFill>
                 <a:latin typeface="Calibri"/>
               </a:rPr>
-              <a:t>• Compreender que, em Cristo, Deus forma UM só povo de muitos povos.</a:t>
+              <a:t>• Em Cristo, Deus forma UM só povo de muitos povos.</a:t>
             </a:r>
           </a:p>
           <a:p>
             <a:pPr>
               <a:spcAft>
-                <a:spcPts val="1000"/>
-              </a:spcAft>
-            </a:pPr>
-            <a:r>
-              <a:rPr sz="2000" b="0" i="0">
+                <a:spcPts val="1400"/>
+              </a:spcAft>
+            </a:pPr>
+            <a:r>
+              <a:rPr sz="2500" b="0" i="0">
                 <a:solidFill>
                   <a:srgbClr val="2B2B2B"/>
                 </a:solidFill>
                 <a:latin typeface="Calibri"/>
               </a:rPr>
-              <a:t>• 1.  UM SÓ POVO — a oliveira de Deus (Romanos 11)</a:t>
+              <a:t>• 1.  Um só povo — a oliveira de Deus (Romanos 11)</a:t>
             </a:r>
           </a:p>
           <a:p>
             <a:pPr>
               <a:spcAft>
-                <a:spcPts val="1000"/>
-              </a:spcAft>
-            </a:pPr>
-            <a:r>
-              <a:rPr sz="2000" b="0" i="0">
+                <a:spcPts val="1400"/>
+              </a:spcAft>
+            </a:pPr>
+            <a:r>
+              <a:rPr sz="2500" b="0" i="0">
                 <a:solidFill>
                   <a:srgbClr val="2B2B2B"/>
                 </a:solidFill>
                 <a:latin typeface="Calibri"/>
               </a:rPr>
-              <a:t>• 2.  UM SÓ CORPO — unidade, diversidade, mutualidade e utilidade (Romanos 12.1-8)</a:t>
+              <a:t>• 2.  Um só corpo — unidade, diversidade, mutualidade e utilidade (Romanos 12.1-8)</a:t>
             </a:r>
           </a:p>
           <a:p>
             <a:pPr>
               <a:spcAft>
-                <a:spcPts val="1000"/>
-              </a:spcAft>
-            </a:pPr>
-            <a:r>
-              <a:rPr sz="2000" b="0" i="0">
+                <a:spcPts val="1400"/>
+              </a:spcAft>
+            </a:pPr>
+            <a:r>
+              <a:rPr sz="2500" b="0" i="0">
                 <a:solidFill>
                   <a:srgbClr val="2B2B2B"/>
                 </a:solidFill>
                 <a:latin typeface="Calibri"/>
               </a:rPr>
-              <a:t>• 3.  UM SÓ AMOR — a vida que sustenta a unidade (Romanos 12.9-21)</a:t>
+              <a:t>• 3.  Um só amor — a vida que sustenta a unidade (Romanos 12.9-21)</a:t>
             </a:r>
           </a:p>
           <a:p>
             <a:pPr>
               <a:spcAft>
-                <a:spcPts val="1000"/>
-              </a:spcAft>
-            </a:pPr>
-            <a:r>
-              <a:rPr sz="2000" b="1" i="0">
+                <a:spcPts val="1400"/>
+              </a:spcAft>
+            </a:pPr>
+            <a:r>
+              <a:rPr sz="2500" b="1" i="0">
                 <a:solidFill>
                   <a:srgbClr val="2E6E6A"/>
                 </a:solidFill>
@@ -9882,7 +9882,7 @@
               </a:spcAft>
             </a:pPr>
             <a:r>
-              <a:rPr sz="1100" b="0" i="0">
+              <a:rPr sz="1200" b="0" i="0">
                 <a:solidFill>
                   <a:srgbClr val="1F3A5F"/>
                 </a:solidFill>
@@ -9901,8 +9901,8 @@
         </p:nvSpPr>
         <p:spPr>
           <a:xfrm>
-            <a:off x="11338560" y="6400800"/>
-            <a:ext cx="731520" cy="365760"/>
+            <a:off x="11247120" y="6400800"/>
+            <a:ext cx="822960" cy="365760"/>
           </a:xfrm>
           <a:prstGeom prst="rect">
             <a:avLst/>
@@ -9924,7 +9924,7 @@
               </a:spcAft>
             </a:pPr>
             <a:r>
-              <a:rPr sz="1100" b="0" i="0">
+              <a:rPr sz="1200" b="0" i="0">
                 <a:solidFill>
                   <a:srgbClr val="1F3A5F"/>
                 </a:solidFill>
@@ -10006,7 +10006,7 @@
         <p:spPr>
           <a:xfrm>
             <a:off x="0" y="0"/>
-            <a:ext cx="12191695" cy="1143000"/>
+            <a:ext cx="12191695" cy="1188720"/>
           </a:xfrm>
           <a:prstGeom prst="rect">
             <a:avLst/>
@@ -10049,8 +10049,8 @@
         </p:nvSpPr>
         <p:spPr>
           <a:xfrm>
-            <a:off x="0" y="1143000"/>
-            <a:ext cx="12191695" cy="73152"/>
+            <a:off x="0" y="1188720"/>
+            <a:ext cx="12191695" cy="82296"/>
           </a:xfrm>
           <a:prstGeom prst="rect">
             <a:avLst/>
@@ -10093,7 +10093,7 @@
         </p:nvSpPr>
         <p:spPr>
           <a:xfrm>
-            <a:off x="548640" y="256032"/>
+            <a:off x="548640" y="201168"/>
             <a:ext cx="11064240" cy="868680"/>
           </a:xfrm>
           <a:prstGeom prst="rect">
@@ -10116,7 +10116,7 @@
               </a:spcAft>
             </a:pPr>
             <a:r>
-              <a:rPr sz="3000" b="1" i="0">
+              <a:rPr sz="3400" b="1" i="0">
                 <a:solidFill>
                   <a:srgbClr val="FFFFFF"/>
                 </a:solidFill>
@@ -10135,8 +10135,8 @@
         </p:nvSpPr>
         <p:spPr>
           <a:xfrm>
-            <a:off x="548640" y="841248"/>
-            <a:ext cx="11064240" cy="320040"/>
+            <a:off x="566928" y="868680"/>
+            <a:ext cx="11064240" cy="365760"/>
           </a:xfrm>
           <a:prstGeom prst="rect">
             <a:avLst/>
@@ -10158,7 +10158,7 @@
               </a:spcAft>
             </a:pPr>
             <a:r>
-              <a:rPr sz="1500" b="1" i="1">
+              <a:rPr sz="1800" b="1" i="1">
                 <a:solidFill>
                   <a:srgbClr val="C9A227"/>
                 </a:solidFill>
@@ -10177,8 +10177,8 @@
         </p:nvSpPr>
         <p:spPr>
           <a:xfrm>
-            <a:off x="822960" y="1554480"/>
-            <a:ext cx="10515600" cy="4572000"/>
+            <a:off x="822960" y="1600200"/>
+            <a:ext cx="10607040" cy="4572000"/>
           </a:xfrm>
           <a:prstGeom prst="rect">
             <a:avLst/>
@@ -10197,13 +10197,13 @@
               </a:spcAft>
             </a:pPr>
             <a:r>
-              <a:rPr sz="2000" b="0" i="0">
+              <a:rPr sz="2600" b="0" i="0">
                 <a:solidFill>
                   <a:srgbClr val="2B2B2B"/>
                 </a:solidFill>
                 <a:latin typeface="Calibri"/>
               </a:rPr>
-              <a:t>• Romanos é o maior tratado teológico do Novo Testamento. Nos capítulos 1–11, Paulo expõe a doutrina; a partir do 12, trata da ética — da teologia para a vida.</a:t>
+              <a:t>• Romanos é o maior tratado teológico do NT. Nos capítulos 1–11, Paulo expõe a doutrina; a partir do 12, trata da vida prática.</a:t>
             </a:r>
           </a:p>
           <a:p>
@@ -10213,29 +10213,29 @@
               </a:spcAft>
             </a:pPr>
             <a:r>
-              <a:rPr sz="2000" b="0" i="0">
+              <a:rPr sz="2600" b="0" i="0">
                 <a:solidFill>
                   <a:srgbClr val="2B2B2B"/>
                 </a:solidFill>
                 <a:latin typeface="Calibri"/>
               </a:rPr>
-              <a:t>• O capítulo 11 termina em adoção: “A Ele seja a glória para sempre!” (Rm 11.36). A unidade nasce da adoração.</a:t>
+              <a:t>• O capítulo 11 termina em adoração: “A Ele seja a glória para sempre!” (Rm 11.36). A unidade nasce da adoração.</a:t>
             </a:r>
           </a:p>
           <a:p>
             <a:pPr>
               <a:spcAft>
-                <a:spcPts val="1000"/>
-              </a:spcAft>
-            </a:pPr>
-            <a:r>
-              <a:rPr sz="2000" b="1" i="0">
+                <a:spcPts val="1400"/>
+              </a:spcAft>
+            </a:pPr>
+            <a:r>
+              <a:rPr sz="2600" b="1" i="0">
                 <a:solidFill>
                   <a:srgbClr val="1F3A5F"/>
                 </a:solidFill>
                 <a:latin typeface="Calibri"/>
               </a:rPr>
-              <a:t>• Não podemos ter um relacionamento vertical correto com Deus se os relacionamentos horizontais com os irmãos estão errados.</a:t>
+              <a:t>• Não há relacionamento vertical correto com Deus se os relacionamentos horizontais com os irmãos estão errados.</a:t>
             </a:r>
           </a:p>
         </p:txBody>
@@ -10271,7 +10271,7 @@
               </a:spcAft>
             </a:pPr>
             <a:r>
-              <a:rPr sz="1100" b="0" i="0">
+              <a:rPr sz="1200" b="0" i="0">
                 <a:solidFill>
                   <a:srgbClr val="1F3A5F"/>
                 </a:solidFill>
@@ -10290,8 +10290,8 @@
         </p:nvSpPr>
         <p:spPr>
           <a:xfrm>
-            <a:off x="11338560" y="6400800"/>
-            <a:ext cx="731520" cy="365760"/>
+            <a:off x="11247120" y="6400800"/>
+            <a:ext cx="822960" cy="365760"/>
           </a:xfrm>
           <a:prstGeom prst="rect">
             <a:avLst/>
@@ -10313,7 +10313,7 @@
               </a:spcAft>
             </a:pPr>
             <a:r>
-              <a:rPr sz="1100" b="0" i="0">
+              <a:rPr sz="1200" b="0" i="0">
                 <a:solidFill>
                   <a:srgbClr val="1F3A5F"/>
                 </a:solidFill>
@@ -10438,8 +10438,8 @@
         </p:nvSpPr>
         <p:spPr>
           <a:xfrm>
-            <a:off x="0" y="2788920"/>
-            <a:ext cx="12191695" cy="54864"/>
+            <a:off x="0" y="2743200"/>
+            <a:ext cx="12191695" cy="64008"/>
           </a:xfrm>
           <a:prstGeom prst="rect">
             <a:avLst/>
@@ -10482,7 +10482,7 @@
         </p:nvSpPr>
         <p:spPr>
           <a:xfrm>
-            <a:off x="914400" y="1828800"/>
+            <a:off x="914400" y="1737360"/>
             <a:ext cx="10332720" cy="914400"/>
           </a:xfrm>
           <a:prstGeom prst="rect">
@@ -10505,7 +10505,7 @@
               </a:spcAft>
             </a:pPr>
             <a:r>
-              <a:rPr sz="2200" b="1" i="0">
+              <a:rPr sz="2800" b="1" i="0">
                 <a:solidFill>
                   <a:srgbClr val="C9A227"/>
                 </a:solidFill>
@@ -10524,8 +10524,8 @@
         </p:nvSpPr>
         <p:spPr>
           <a:xfrm>
-            <a:off x="914400" y="2926080"/>
-            <a:ext cx="10332720" cy="1828800"/>
+            <a:off x="640080" y="2880360"/>
+            <a:ext cx="10881360" cy="1828800"/>
           </a:xfrm>
           <a:prstGeom prst="rect">
             <a:avLst/>
@@ -10547,7 +10547,7 @@
               </a:spcAft>
             </a:pPr>
             <a:r>
-              <a:rPr sz="4000" b="1" i="0">
+              <a:rPr sz="5000" b="1" i="0">
                 <a:solidFill>
                   <a:srgbClr val="FFFFFF"/>
                 </a:solidFill>
@@ -10566,7 +10566,7 @@
         </p:nvSpPr>
         <p:spPr>
           <a:xfrm>
-            <a:off x="914400" y="4572000"/>
+            <a:off x="914400" y="4663440"/>
             <a:ext cx="10332720" cy="731520"/>
           </a:xfrm>
           <a:prstGeom prst="rect">
@@ -10589,7 +10589,7 @@
               </a:spcAft>
             </a:pPr>
             <a:r>
-              <a:rPr sz="2000" b="0" i="1">
+              <a:rPr sz="2400" b="0" i="1">
                 <a:solidFill>
                   <a:srgbClr val="F6F2E8"/>
                 </a:solidFill>
@@ -10671,7 +10671,7 @@
         <p:spPr>
           <a:xfrm>
             <a:off x="0" y="0"/>
-            <a:ext cx="12191695" cy="1143000"/>
+            <a:ext cx="12191695" cy="1188720"/>
           </a:xfrm>
           <a:prstGeom prst="rect">
             <a:avLst/>
@@ -10714,8 +10714,8 @@
         </p:nvSpPr>
         <p:spPr>
           <a:xfrm>
-            <a:off x="0" y="1143000"/>
-            <a:ext cx="12191695" cy="73152"/>
+            <a:off x="0" y="1188720"/>
+            <a:ext cx="12191695" cy="82296"/>
           </a:xfrm>
           <a:prstGeom prst="rect">
             <a:avLst/>
@@ -10758,7 +10758,7 @@
         </p:nvSpPr>
         <p:spPr>
           <a:xfrm>
-            <a:off x="548640" y="256032"/>
+            <a:off x="548640" y="201168"/>
             <a:ext cx="11064240" cy="868680"/>
           </a:xfrm>
           <a:prstGeom prst="rect">
@@ -10781,7 +10781,7 @@
               </a:spcAft>
             </a:pPr>
             <a:r>
-              <a:rPr sz="3000" b="1" i="0">
+              <a:rPr sz="3400" b="1" i="0">
                 <a:solidFill>
                   <a:srgbClr val="FFFFFF"/>
                 </a:solidFill>
@@ -10800,8 +10800,8 @@
         </p:nvSpPr>
         <p:spPr>
           <a:xfrm>
-            <a:off x="548640" y="841248"/>
-            <a:ext cx="11064240" cy="320040"/>
+            <a:off x="566928" y="868680"/>
+            <a:ext cx="11064240" cy="365760"/>
           </a:xfrm>
           <a:prstGeom prst="rect">
             <a:avLst/>
@@ -10823,7 +10823,7 @@
               </a:spcAft>
             </a:pPr>
             <a:r>
-              <a:rPr sz="1500" b="1" i="1">
+              <a:rPr sz="1800" b="1" i="1">
                 <a:solidFill>
                   <a:srgbClr val="C9A227"/>
                 </a:solidFill>
@@ -10842,8 +10842,8 @@
         </p:nvSpPr>
         <p:spPr>
           <a:xfrm>
-            <a:off x="822960" y="1554480"/>
-            <a:ext cx="10515600" cy="4572000"/>
+            <a:off x="822960" y="1600200"/>
+            <a:ext cx="10607040" cy="4572000"/>
           </a:xfrm>
           <a:prstGeom prst="rect">
             <a:avLst/>
@@ -10858,49 +10858,49 @@
           <a:p>
             <a:pPr>
               <a:spcAft>
-                <a:spcPts val="1200"/>
-              </a:spcAft>
-            </a:pPr>
-            <a:r>
-              <a:rPr sz="2000" b="0" i="0">
+                <a:spcPts val="1400"/>
+              </a:spcAft>
+            </a:pPr>
+            <a:r>
+              <a:rPr sz="2600" b="0" i="0">
                 <a:solidFill>
                   <a:srgbClr val="2B2B2B"/>
                 </a:solidFill>
                 <a:latin typeface="Calibri"/>
               </a:rPr>
-              <a:t>• “De modo nenhum!” — Deus não rejeitou Israel. O próprio Paulo é a prova: israelita, da descendência de Abraão.</a:t>
+              <a:t>• “De modo nenhum!” Deus não rejeitou Israel. O próprio Paulo é a prova: israelita, da descendência de Abraão.</a:t>
             </a:r>
           </a:p>
           <a:p>
             <a:pPr>
               <a:spcAft>
-                <a:spcPts val="1200"/>
-              </a:spcAft>
-            </a:pPr>
-            <a:r>
-              <a:rPr sz="2000" b="0" i="0">
+                <a:spcPts val="1400"/>
+              </a:spcAft>
+            </a:pPr>
+            <a:r>
+              <a:rPr sz="2600" b="0" i="0">
                 <a:solidFill>
                   <a:srgbClr val="2B2B2B"/>
                 </a:solidFill>
                 <a:latin typeface="Calibri"/>
               </a:rPr>
-              <a:t>• A rejeição de Israel é apenas parcial: sempre houve um remanescente fiel — como os 7.000 que não dobraram os joelhos a Baal.</a:t>
+              <a:t>• A rejeição é apenas parcial: sempre houve um remanescente fiel — como os 7.000 que não dobraram os joelhos a Baal.</a:t>
             </a:r>
           </a:p>
           <a:p>
             <a:pPr>
               <a:spcAft>
-                <a:spcPts val="1000"/>
-              </a:spcAft>
-            </a:pPr>
-            <a:r>
-              <a:rPr sz="2000" b="1" i="0">
+                <a:spcPts val="1400"/>
+              </a:spcAft>
+            </a:pPr>
+            <a:r>
+              <a:rPr sz="2600" b="1" i="0">
                 <a:solidFill>
                   <a:srgbClr val="1F3A5F"/>
                 </a:solidFill>
                 <a:latin typeface="Calibri"/>
               </a:rPr>
-              <a:t>• Esse remanescente existe “segundo a eleição da graça” (11.5). Não por obras — do contrário, a graça já não seria graça.</a:t>
+              <a:t>• Esse remanescente existe “segundo a eleição da graça” (11.5). Não por obras — senão a graça já não seria graça.</a:t>
             </a:r>
           </a:p>
         </p:txBody>
@@ -10936,7 +10936,7 @@
               </a:spcAft>
             </a:pPr>
             <a:r>
-              <a:rPr sz="1100" b="0" i="0">
+              <a:rPr sz="1200" b="0" i="0">
                 <a:solidFill>
                   <a:srgbClr val="1F3A5F"/>
                 </a:solidFill>
@@ -10955,8 +10955,8 @@
         </p:nvSpPr>
         <p:spPr>
           <a:xfrm>
-            <a:off x="11338560" y="6400800"/>
-            <a:ext cx="731520" cy="365760"/>
+            <a:off x="11247120" y="6400800"/>
+            <a:ext cx="822960" cy="365760"/>
           </a:xfrm>
           <a:prstGeom prst="rect">
             <a:avLst/>
@@ -10978,7 +10978,7 @@
               </a:spcAft>
             </a:pPr>
             <a:r>
-              <a:rPr sz="1100" b="0" i="0">
+              <a:rPr sz="1200" b="0" i="0">
                 <a:solidFill>
                   <a:srgbClr val="1F3A5F"/>
                 </a:solidFill>
@@ -11060,7 +11060,7 @@
         <p:spPr>
           <a:xfrm>
             <a:off x="0" y="0"/>
-            <a:ext cx="12191695" cy="1143000"/>
+            <a:ext cx="12191695" cy="1188720"/>
           </a:xfrm>
           <a:prstGeom prst="rect">
             <a:avLst/>
@@ -11103,8 +11103,8 @@
         </p:nvSpPr>
         <p:spPr>
           <a:xfrm>
-            <a:off x="0" y="1143000"/>
-            <a:ext cx="12191695" cy="73152"/>
+            <a:off x="0" y="1188720"/>
+            <a:ext cx="12191695" cy="82296"/>
           </a:xfrm>
           <a:prstGeom prst="rect">
             <a:avLst/>
@@ -11147,7 +11147,7 @@
         </p:nvSpPr>
         <p:spPr>
           <a:xfrm>
-            <a:off x="548640" y="256032"/>
+            <a:off x="548640" y="201168"/>
             <a:ext cx="11064240" cy="868680"/>
           </a:xfrm>
           <a:prstGeom prst="rect">
@@ -11170,7 +11170,7 @@
               </a:spcAft>
             </a:pPr>
             <a:r>
-              <a:rPr sz="3000" b="1" i="0">
+              <a:rPr sz="3400" b="1" i="0">
                 <a:solidFill>
                   <a:srgbClr val="FFFFFF"/>
                 </a:solidFill>
@@ -11189,8 +11189,8 @@
         </p:nvSpPr>
         <p:spPr>
           <a:xfrm>
-            <a:off x="548640" y="841248"/>
-            <a:ext cx="11064240" cy="320040"/>
+            <a:off x="566928" y="868680"/>
+            <a:ext cx="11064240" cy="365760"/>
           </a:xfrm>
           <a:prstGeom prst="rect">
             <a:avLst/>
@@ -11212,7 +11212,7 @@
               </a:spcAft>
             </a:pPr>
             <a:r>
-              <a:rPr sz="1500" b="1" i="1">
+              <a:rPr sz="1800" b="1" i="1">
                 <a:solidFill>
                   <a:srgbClr val="C9A227"/>
                 </a:solidFill>
@@ -11231,8 +11231,8 @@
         </p:nvSpPr>
         <p:spPr>
           <a:xfrm>
-            <a:off x="822960" y="1554480"/>
-            <a:ext cx="10515600" cy="3657600"/>
+            <a:off x="822960" y="1600200"/>
+            <a:ext cx="10607040" cy="4572000"/>
           </a:xfrm>
           <a:prstGeom prst="rect">
             <a:avLst/>
@@ -11247,49 +11247,49 @@
           <a:p>
             <a:pPr>
               <a:spcAft>
-                <a:spcPts val="1200"/>
-              </a:spcAft>
-            </a:pPr>
-            <a:r>
-              <a:rPr sz="2000" b="0" i="0">
+                <a:spcPts val="1400"/>
+              </a:spcAft>
+            </a:pPr>
+            <a:r>
+              <a:rPr sz="2500" b="0" i="0">
                 <a:solidFill>
                   <a:srgbClr val="2B2B2B"/>
                 </a:solidFill>
                 <a:latin typeface="Calibri"/>
               </a:rPr>
-              <a:t>• A queda de Israel abriu espaço para a salvação dos gentios — e isso, por sua vez, deve provocar Israel ao ciûme santo, para a sua restauração.</a:t>
+              <a:t>• A queda de Israel abriu espaço para a salvação dos gentios — e isso deve provocar Israel a um santo ciúme, para a sua restauração.</a:t>
             </a:r>
           </a:p>
           <a:p>
             <a:pPr>
               <a:spcAft>
-                <a:spcPts val="1200"/>
-              </a:spcAft>
-            </a:pPr>
-            <a:r>
-              <a:rPr sz="2000" b="0" i="0">
+                <a:spcPts val="1400"/>
+              </a:spcAft>
+            </a:pPr>
+            <a:r>
+              <a:rPr sz="2500" b="0" i="0">
                 <a:solidFill>
                   <a:srgbClr val="2B2B2B"/>
                 </a:solidFill>
                 <a:latin typeface="Calibri"/>
               </a:rPr>
-              <a:t>• Raiz e oliveira: a raiz é Abraão; os ramos naturais são os judeus; os gentios são ramos silvestres enxertados pela fé.</a:t>
+              <a:t>• A raiz é Abraão; os ramos naturais são os judeus; os gentios são ramos silvestres enxertados pela fé.</a:t>
             </a:r>
           </a:p>
           <a:p>
             <a:pPr>
               <a:spcAft>
-                <a:spcPts val="1000"/>
-              </a:spcAft>
-            </a:pPr>
-            <a:r>
-              <a:rPr sz="2000" b="1" i="0">
+                <a:spcPts val="1400"/>
+              </a:spcAft>
+            </a:pPr>
+            <a:r>
+              <a:rPr sz="2500" b="1" i="0">
                 <a:solidFill>
                   <a:srgbClr val="1F3A5F"/>
                 </a:solidFill>
                 <a:latin typeface="Calibri"/>
               </a:rPr>
-              <a:t>• “Não te glories contra os ramos” (11.18). O gentio não sustenta a raiz — a raiz é que o sustenta. Lugar de humildade, não de orgulho.</a:t>
+              <a:t>• “Não te glories contra os ramos” (11.18): o gentio não sustenta a raiz — a raiz é que o sustenta. Humildade, não orgulho.</a:t>
             </a:r>
           </a:p>
         </p:txBody>
@@ -11325,7 +11325,7 @@
               </a:spcAft>
             </a:pPr>
             <a:r>
-              <a:rPr sz="1100" b="0" i="0">
+              <a:rPr sz="1200" b="0" i="0">
                 <a:solidFill>
                   <a:srgbClr val="1F3A5F"/>
                 </a:solidFill>
@@ -11344,8 +11344,8 @@
         </p:nvSpPr>
         <p:spPr>
           <a:xfrm>
-            <a:off x="11338560" y="6400800"/>
-            <a:ext cx="731520" cy="365760"/>
+            <a:off x="11247120" y="6400800"/>
+            <a:ext cx="822960" cy="365760"/>
           </a:xfrm>
           <a:prstGeom prst="rect">
             <a:avLst/>
@@ -11367,7 +11367,7 @@
               </a:spcAft>
             </a:pPr>
             <a:r>
-              <a:rPr sz="1100" b="0" i="0">
+              <a:rPr sz="1200" b="0" i="0">
                 <a:solidFill>
                   <a:srgbClr val="1F3A5F"/>
                 </a:solidFill>
@@ -11492,8 +11492,8 @@
         </p:nvSpPr>
         <p:spPr>
           <a:xfrm>
-            <a:off x="731520" y="822960"/>
-            <a:ext cx="10698480" cy="914400"/>
+            <a:off x="731520" y="640080"/>
+            <a:ext cx="10698480" cy="822960"/>
           </a:xfrm>
           <a:prstGeom prst="rect">
             <a:avLst/>
@@ -11515,7 +11515,7 @@
               </a:spcAft>
             </a:pPr>
             <a:r>
-              <a:rPr sz="2000" b="1" i="0">
+              <a:rPr sz="2600" b="1" i="0">
                 <a:solidFill>
                   <a:srgbClr val="F6F2E8"/>
                 </a:solidFill>
@@ -11534,8 +11534,8 @@
         </p:nvSpPr>
         <p:spPr>
           <a:xfrm>
-            <a:off x="822960" y="1828800"/>
-            <a:ext cx="10515600" cy="1828800"/>
+            <a:off x="822960" y="1691640"/>
+            <a:ext cx="10515600" cy="2103120"/>
           </a:xfrm>
           <a:prstGeom prst="roundRect">
             <a:avLst/>
@@ -11565,7 +11565,7 @@
           </a:fontRef>
         </p:style>
         <p:txBody>
-          <a:bodyPr rtlCol="0" anchor="ctr" wrap="square" lIns="365760" rIns="320040"/>
+          <a:bodyPr rtlCol="0" anchor="ctr" wrap="square" lIns="411480" rIns="365760"/>
           <a:lstStyle/>
           <a:p>
             <a:pPr algn="l">
@@ -11577,13 +11577,13 @@
               </a:spcAft>
             </a:pPr>
             <a:r>
-              <a:rPr sz="1900" b="0" i="1">
+              <a:rPr sz="2500" b="0" i="1">
                 <a:solidFill>
                   <a:srgbClr val="162A45"/>
                 </a:solidFill>
                 <a:latin typeface="Georgia"/>
               </a:rPr>
-              <a:t>“Uma só oliveira representa todos os salvos, sem importar a sua origem. Para judeus e gentios, a salvação é a mesma: sobre a base da expiação de Cristo, pela graça, por meio da fé.”</a:t>
+              <a:t>“Uma só oliveira representa todos os salvos, sem importar a origem. Para judeus e gentios, a salvação é a mesma: pela graça, por meio da fé, sobre a base da expiação de Cristo.”</a:t>
             </a:r>
           </a:p>
           <a:p>
@@ -11596,7 +11596,7 @@
               </a:spcAft>
             </a:pPr>
             <a:r>
-              <a:rPr sz="1500" b="1" i="0">
+              <a:rPr sz="1900" b="1" i="0">
                 <a:solidFill>
                   <a:srgbClr val="2E6E6A"/>
                 </a:solidFill>
@@ -11615,8 +11615,8 @@
         </p:nvSpPr>
         <p:spPr>
           <a:xfrm>
-            <a:off x="822960" y="1828800"/>
-            <a:ext cx="118872" cy="1828800"/>
+            <a:off x="822960" y="1691640"/>
+            <a:ext cx="137160" cy="2103120"/>
           </a:xfrm>
           <a:prstGeom prst="rect">
             <a:avLst/>
@@ -11659,8 +11659,8 @@
         </p:nvSpPr>
         <p:spPr>
           <a:xfrm>
-            <a:off x="822960" y="4297680"/>
-            <a:ext cx="10515600" cy="1828800"/>
+            <a:off x="822960" y="4206240"/>
+            <a:ext cx="10515600" cy="2194560"/>
           </a:xfrm>
           <a:prstGeom prst="rect">
             <a:avLst/>
@@ -11675,11 +11675,11 @@
           <a:p>
             <a:pPr>
               <a:spcAft>
-                <a:spcPts val="1000"/>
-              </a:spcAft>
-            </a:pPr>
-            <a:r>
-              <a:rPr sz="2100" b="1" i="0">
+                <a:spcPts val="1400"/>
+              </a:spcAft>
+            </a:pPr>
+            <a:r>
+              <a:rPr sz="2600" b="1" i="0">
                 <a:solidFill>
                   <a:srgbClr val="FFFFFF"/>
                 </a:solidFill>
@@ -11691,17 +11691,17 @@
           <a:p>
             <a:pPr>
               <a:spcAft>
-                <a:spcPts val="1000"/>
-              </a:spcAft>
-            </a:pPr>
-            <a:r>
-              <a:rPr sz="2000" b="0" i="0">
+                <a:spcPts val="1400"/>
+              </a:spcAft>
+            </a:pPr>
+            <a:r>
+              <a:rPr sz="2500" b="0" i="0">
                 <a:solidFill>
                   <a:srgbClr val="F6F2E8"/>
                 </a:solidFill>
                 <a:latin typeface="Calibri"/>
               </a:rPr>
-              <a:t>• A unidade do povo de Deus não é uniformidade étnica ou cultural — é união na mesma raiz, pela mesma graça.</a:t>
+              <a:t>• A unidade do povo de Deus não é uniformidade — é união na mesma raiz, pela mesma graça.</a:t>
             </a:r>
           </a:p>
         </p:txBody>
@@ -11820,8 +11820,8 @@
         </p:nvSpPr>
         <p:spPr>
           <a:xfrm>
-            <a:off x="0" y="2788920"/>
-            <a:ext cx="12191695" cy="54864"/>
+            <a:off x="0" y="2743200"/>
+            <a:ext cx="12191695" cy="64008"/>
           </a:xfrm>
           <a:prstGeom prst="rect">
             <a:avLst/>
@@ -11864,7 +11864,7 @@
         </p:nvSpPr>
         <p:spPr>
           <a:xfrm>
-            <a:off x="914400" y="1828800"/>
+            <a:off x="914400" y="1737360"/>
             <a:ext cx="10332720" cy="914400"/>
           </a:xfrm>
           <a:prstGeom prst="rect">
@@ -11887,7 +11887,7 @@
               </a:spcAft>
             </a:pPr>
             <a:r>
-              <a:rPr sz="2200" b="1" i="0">
+              <a:rPr sz="2800" b="1" i="0">
                 <a:solidFill>
                   <a:srgbClr val="C9A227"/>
                 </a:solidFill>
@@ -11906,8 +11906,8 @@
         </p:nvSpPr>
         <p:spPr>
           <a:xfrm>
-            <a:off x="914400" y="2926080"/>
-            <a:ext cx="10332720" cy="1828800"/>
+            <a:off x="640080" y="2880360"/>
+            <a:ext cx="10881360" cy="1828800"/>
           </a:xfrm>
           <a:prstGeom prst="rect">
             <a:avLst/>
@@ -11929,7 +11929,7 @@
               </a:spcAft>
             </a:pPr>
             <a:r>
-              <a:rPr sz="4000" b="1" i="0">
+              <a:rPr sz="5000" b="1" i="0">
                 <a:solidFill>
                   <a:srgbClr val="FFFFFF"/>
                 </a:solidFill>
@@ -11948,7 +11948,7 @@
         </p:nvSpPr>
         <p:spPr>
           <a:xfrm>
-            <a:off x="914400" y="4572000"/>
+            <a:off x="914400" y="4663440"/>
             <a:ext cx="10332720" cy="731520"/>
           </a:xfrm>
           <a:prstGeom prst="rect">
@@ -11971,7 +11971,7 @@
               </a:spcAft>
             </a:pPr>
             <a:r>
-              <a:rPr sz="2000" b="0" i="1">
+              <a:rPr sz="2400" b="0" i="1">
                 <a:solidFill>
                   <a:srgbClr val="F6F2E8"/>
                 </a:solidFill>

</xml_diff>